<commit_message>
C4 M2: infografía con diagramación más aireada sobre la versión de Andrea
Co-Authored-By: Claude Opus 5.5 <noreply@anthropic.com>
Claude-Session: https://claude.ai/code/session_01ECfkxKzanoc9tBzEYwq5z6
</commit_message>
<xml_diff>
--- a/entregas/curso4_modulo2/C4_M2_03_Infografia_Creatividad_pensamiento_de_diseno_e_innovacion_EDITABLE.pptx
+++ b/entregas/curso4_modulo2/C4_M2_03_Infografia_Creatividad_pensamiento_de_diseno_e_innovacion_EDITABLE.pptx
@@ -3144,7 +3144,7 @@
         </p:nvSpPr>
         <p:spPr>
           <a:xfrm>
-            <a:off x="-1651000" y="22733000"/>
+            <a:off x="-1905000" y="22860000"/>
             <a:ext cx="3810000" cy="3810000"/>
           </a:xfrm>
           <a:prstGeom prst="donut">
@@ -3238,7 +3238,7 @@
         </p:nvSpPr>
         <p:spPr>
           <a:xfrm>
-            <a:off x="762000" y="711200"/>
+            <a:off x="762000" y="762000"/>
             <a:ext cx="5461000" cy="457200"/>
           </a:xfrm>
           <a:prstGeom prst="roundRect">
@@ -3268,7 +3268,7 @@
         </p:nvSpPr>
         <p:spPr>
           <a:xfrm>
-            <a:off x="762000" y="711200"/>
+            <a:off x="762000" y="762000"/>
             <a:ext cx="5461000" cy="457200"/>
           </a:xfrm>
           <a:prstGeom prst="rect">
@@ -3303,8 +3303,8 @@
         </p:nvSpPr>
         <p:spPr>
           <a:xfrm>
-            <a:off x="762000" y="1473200"/>
-            <a:ext cx="152400" cy="1676400"/>
+            <a:off x="762000" y="1549400"/>
+            <a:ext cx="152400" cy="1727200"/>
           </a:xfrm>
           <a:prstGeom prst="roundRect">
             <a:avLst>
@@ -3341,8 +3341,8 @@
         </p:nvSpPr>
         <p:spPr>
           <a:xfrm>
-            <a:off x="1168400" y="1371600"/>
-            <a:ext cx="11430000" cy="1905000"/>
+            <a:off x="1168400" y="1473200"/>
+            <a:ext cx="11176000" cy="1905000"/>
           </a:xfrm>
           <a:prstGeom prst="rect">
             <a:avLst/>
@@ -3380,8 +3380,8 @@
         </p:nvSpPr>
         <p:spPr>
           <a:xfrm>
-            <a:off x="762000" y="3429000"/>
-            <a:ext cx="12192000" cy="381000"/>
+            <a:off x="762000" y="3632200"/>
+            <a:ext cx="12192000" cy="406400"/>
           </a:xfrm>
           <a:prstGeom prst="rect">
             <a:avLst/>
@@ -3396,7 +3396,7 @@
           <a:p>
             <a:pPr algn="l"/>
             <a:r>
-              <a:rPr sz="1900" b="0">
+              <a:rPr sz="2000" b="0">
                 <a:solidFill>
                   <a:srgbClr val="455971"/>
                 </a:solidFill>
@@ -3405,7 +3405,7 @@
               <a:t>Tres conceptos diferentes, un mismo propósito: </a:t>
             </a:r>
             <a:r>
-              <a:rPr sz="1900" b="1">
+              <a:rPr sz="2000" b="1">
                 <a:solidFill>
                   <a:srgbClr val="4E6AD5"/>
                 </a:solidFill>
@@ -3424,8 +3424,8 @@
         </p:nvSpPr>
         <p:spPr>
           <a:xfrm>
-            <a:off x="762000" y="4318000"/>
-            <a:ext cx="12192000" cy="4673600"/>
+            <a:off x="762000" y="4851400"/>
+            <a:ext cx="12192000" cy="4724400"/>
           </a:xfrm>
           <a:prstGeom prst="roundRect">
             <a:avLst>
@@ -3435,9 +3435,9 @@
           <a:solidFill>
             <a:srgbClr val="FFFFFF"/>
           </a:solidFill>
-          <a:ln w="28575">
+          <a:ln w="31750">
             <a:solidFill>
-              <a:srgbClr val="FFD900"/>
+              <a:srgbClr val="F2C200"/>
             </a:solidFill>
           </a:ln>
           <a:effectLst/>
@@ -3456,8 +3456,8 @@
         </p:nvSpPr>
         <p:spPr>
           <a:xfrm>
-            <a:off x="762000" y="4318000"/>
-            <a:ext cx="177800" cy="4673600"/>
+            <a:off x="762000" y="4851400"/>
+            <a:ext cx="177800" cy="4724400"/>
           </a:xfrm>
           <a:prstGeom prst="rect">
             <a:avLst/>
@@ -3484,7 +3484,7 @@
         </p:nvSpPr>
         <p:spPr>
           <a:xfrm>
-            <a:off x="1244600" y="4648200"/>
+            <a:off x="1270000" y="5232400"/>
             <a:ext cx="1066800" cy="1066800"/>
           </a:xfrm>
           <a:prstGeom prst="ellipse">
@@ -3520,7 +3520,7 @@
         </p:blipFill>
         <p:spPr>
           <a:xfrm>
-            <a:off x="1485900" y="4889500"/>
+            <a:off x="1511300" y="5473700"/>
             <a:ext cx="584200" cy="584200"/>
           </a:xfrm>
           <a:prstGeom prst="rect">
@@ -3536,8 +3536,8 @@
         </p:nvSpPr>
         <p:spPr>
           <a:xfrm>
-            <a:off x="2540000" y="4673600"/>
-            <a:ext cx="6350000" cy="584200"/>
+            <a:off x="2590800" y="5257800"/>
+            <a:ext cx="6096000" cy="584200"/>
           </a:xfrm>
           <a:prstGeom prst="rect">
             <a:avLst/>
@@ -3571,8 +3571,8 @@
         </p:nvSpPr>
         <p:spPr>
           <a:xfrm>
-            <a:off x="2540000" y="5283200"/>
-            <a:ext cx="6350000" cy="381000"/>
+            <a:off x="2590800" y="5867400"/>
+            <a:ext cx="6096000" cy="381000"/>
           </a:xfrm>
           <a:prstGeom prst="rect">
             <a:avLst/>
@@ -3606,8 +3606,8 @@
         </p:nvSpPr>
         <p:spPr>
           <a:xfrm>
-            <a:off x="1244600" y="5943600"/>
-            <a:ext cx="7620000" cy="1066800"/>
+            <a:off x="1270000" y="6527800"/>
+            <a:ext cx="7416800" cy="1143000"/>
           </a:xfrm>
           <a:prstGeom prst="rect">
             <a:avLst/>
@@ -3622,11 +3622,11 @@
           <a:p>
             <a:pPr algn="l">
               <a:lnSpc>
-                <a:spcPct val="112000"/>
+                <a:spcPct val="118000"/>
               </a:lnSpc>
             </a:pPr>
             <a:r>
-              <a:rPr sz="1600" b="0">
+              <a:rPr sz="1700" b="0">
                 <a:solidFill>
                   <a:srgbClr val="455971"/>
                 </a:solidFill>
@@ -3645,8 +3645,8 @@
         </p:nvSpPr>
         <p:spPr>
           <a:xfrm>
-            <a:off x="1244600" y="6985000"/>
-            <a:ext cx="7620000" cy="1651000"/>
+            <a:off x="1270000" y="7772400"/>
+            <a:ext cx="7416800" cy="1498600"/>
           </a:xfrm>
           <a:prstGeom prst="roundRect">
             <a:avLst>
@@ -3675,8 +3675,8 @@
         </p:nvSpPr>
         <p:spPr>
           <a:xfrm>
-            <a:off x="1498600" y="7264400"/>
-            <a:ext cx="152400" cy="152400"/>
+            <a:off x="1574800" y="8128000"/>
+            <a:ext cx="139700" cy="139700"/>
           </a:xfrm>
           <a:prstGeom prst="ellipse">
             <a:avLst/>
@@ -3703,8 +3703,8 @@
         </p:nvSpPr>
         <p:spPr>
           <a:xfrm>
-            <a:off x="1803400" y="7162800"/>
-            <a:ext cx="6858000" cy="355600"/>
+            <a:off x="1879600" y="8013700"/>
+            <a:ext cx="6604000" cy="381000"/>
           </a:xfrm>
           <a:prstGeom prst="rect">
             <a:avLst/>
@@ -3719,7 +3719,7 @@
           <a:p>
             <a:pPr algn="l"/>
             <a:r>
-              <a:rPr sz="1550" b="0">
+              <a:rPr sz="1600" b="0">
                 <a:solidFill>
                   <a:srgbClr val="3D2159"/>
                 </a:solidFill>
@@ -3738,8 +3738,8 @@
         </p:nvSpPr>
         <p:spPr>
           <a:xfrm>
-            <a:off x="1498600" y="7721600"/>
-            <a:ext cx="152400" cy="152400"/>
+            <a:off x="1574800" y="8534400"/>
+            <a:ext cx="139700" cy="139700"/>
           </a:xfrm>
           <a:prstGeom prst="ellipse">
             <a:avLst/>
@@ -3766,8 +3766,8 @@
         </p:nvSpPr>
         <p:spPr>
           <a:xfrm>
-            <a:off x="1803400" y="7620000"/>
-            <a:ext cx="6858000" cy="355600"/>
+            <a:off x="1879600" y="8420100"/>
+            <a:ext cx="6604000" cy="381000"/>
           </a:xfrm>
           <a:prstGeom prst="rect">
             <a:avLst/>
@@ -3782,7 +3782,7 @@
           <a:p>
             <a:pPr algn="l"/>
             <a:r>
-              <a:rPr sz="1550" b="0">
+              <a:rPr sz="1600" b="0">
                 <a:solidFill>
                   <a:srgbClr val="3D2159"/>
                 </a:solidFill>
@@ -3801,8 +3801,8 @@
         </p:nvSpPr>
         <p:spPr>
           <a:xfrm>
-            <a:off x="1498600" y="8178800"/>
-            <a:ext cx="152400" cy="152400"/>
+            <a:off x="1574800" y="8940800"/>
+            <a:ext cx="139700" cy="139700"/>
           </a:xfrm>
           <a:prstGeom prst="ellipse">
             <a:avLst/>
@@ -3829,8 +3829,8 @@
         </p:nvSpPr>
         <p:spPr>
           <a:xfrm>
-            <a:off x="1803400" y="8077200"/>
-            <a:ext cx="6858000" cy="355600"/>
+            <a:off x="1879600" y="8826500"/>
+            <a:ext cx="6604000" cy="381000"/>
           </a:xfrm>
           <a:prstGeom prst="rect">
             <a:avLst/>
@@ -3845,7 +3845,7 @@
           <a:p>
             <a:pPr algn="l"/>
             <a:r>
-              <a:rPr sz="1550" b="0">
+              <a:rPr sz="1600" b="0">
                 <a:solidFill>
                   <a:srgbClr val="3D2159"/>
                 </a:solidFill>
@@ -3858,14 +3858,14 @@
       </p:sp>
       <p:sp>
         <p:nvSpPr>
-          <p:cNvPr id="25" name="Rounded Rectangle 24"/>
+          <p:cNvPr id="25" name="Imagen 1 · Creatividad — reemplazar con la foto (Relleno con imagen)"/>
           <p:cNvSpPr/>
           <p:nvPr/>
         </p:nvSpPr>
         <p:spPr>
           <a:xfrm>
-            <a:off x="9194800" y="4648200"/>
-            <a:ext cx="3429000" cy="4013200"/>
+            <a:off x="9093200" y="5232400"/>
+            <a:ext cx="3454400" cy="3962400"/>
           </a:xfrm>
           <a:prstGeom prst="roundRect">
             <a:avLst>
@@ -3886,6 +3886,1399 @@
           <a:p/>
         </p:txBody>
       </p:sp>
+      <p:sp>
+        <p:nvSpPr>
+          <p:cNvPr id="29" name="Oval 28"/>
+          <p:cNvSpPr/>
+          <p:nvPr/>
+        </p:nvSpPr>
+        <p:spPr>
+          <a:xfrm>
+            <a:off x="6578600" y="9601200"/>
+            <a:ext cx="558800" cy="558800"/>
+          </a:xfrm>
+          <a:prstGeom prst="ellipse">
+            <a:avLst/>
+          </a:prstGeom>
+          <a:solidFill>
+            <a:srgbClr val="FFFFFF"/>
+          </a:solidFill>
+          <a:ln w="31750">
+            <a:solidFill>
+              <a:srgbClr val="2BB3C0"/>
+            </a:solidFill>
+          </a:ln>
+          <a:effectLst/>
+        </p:spPr>
+        <p:txBody>
+          <a:bodyPr rtlCol="0" anchor="ctr"/>
+          <a:lstStyle/>
+          <a:p/>
+        </p:txBody>
+      </p:sp>
+      <p:pic>
+        <p:nvPicPr>
+          <p:cNvPr id="30" name="Picture 29" descr="plus_bl.png"/>
+          <p:cNvPicPr>
+            <a:picLocks noChangeAspect="1"/>
+          </p:cNvPicPr>
+          <p:nvPr/>
+        </p:nvPicPr>
+        <p:blipFill>
+          <a:blip r:embed="rId5"/>
+          <a:stretch>
+            <a:fillRect/>
+          </a:stretch>
+        </p:blipFill>
+        <p:spPr>
+          <a:xfrm>
+            <a:off x="6692900" y="9715500"/>
+            <a:ext cx="330200" cy="330200"/>
+          </a:xfrm>
+          <a:prstGeom prst="rect">
+            <a:avLst/>
+          </a:prstGeom>
+        </p:spPr>
+      </p:pic>
+      <p:sp>
+        <p:nvSpPr>
+          <p:cNvPr id="31" name="Rounded Rectangle 30"/>
+          <p:cNvSpPr/>
+          <p:nvPr/>
+        </p:nvSpPr>
+        <p:spPr>
+          <a:xfrm>
+            <a:off x="762000" y="10185400"/>
+            <a:ext cx="12192000" cy="4724400"/>
+          </a:xfrm>
+          <a:prstGeom prst="roundRect">
+            <a:avLst>
+              <a:gd name="adj" fmla="val 4891"/>
+            </a:avLst>
+          </a:prstGeom>
+          <a:solidFill>
+            <a:srgbClr val="FFFFFF"/>
+          </a:solidFill>
+          <a:ln w="31750">
+            <a:solidFill>
+              <a:srgbClr val="664092"/>
+            </a:solidFill>
+          </a:ln>
+          <a:effectLst/>
+        </p:spPr>
+        <p:txBody>
+          <a:bodyPr rtlCol="0" anchor="ctr"/>
+          <a:lstStyle/>
+          <a:p/>
+        </p:txBody>
+      </p:sp>
+      <p:sp>
+        <p:nvSpPr>
+          <p:cNvPr id="32" name="Rectangle 31"/>
+          <p:cNvSpPr/>
+          <p:nvPr/>
+        </p:nvSpPr>
+        <p:spPr>
+          <a:xfrm>
+            <a:off x="762000" y="10185400"/>
+            <a:ext cx="177800" cy="4724400"/>
+          </a:xfrm>
+          <a:prstGeom prst="rect">
+            <a:avLst/>
+          </a:prstGeom>
+          <a:solidFill>
+            <a:srgbClr val="664092"/>
+          </a:solidFill>
+          <a:ln>
+            <a:noFill/>
+          </a:ln>
+          <a:effectLst/>
+        </p:spPr>
+        <p:txBody>
+          <a:bodyPr rtlCol="0" anchor="ctr"/>
+          <a:lstStyle/>
+          <a:p/>
+        </p:txBody>
+      </p:sp>
+      <p:sp>
+        <p:nvSpPr>
+          <p:cNvPr id="33" name="Oval 32"/>
+          <p:cNvSpPr/>
+          <p:nvPr/>
+        </p:nvSpPr>
+        <p:spPr>
+          <a:xfrm>
+            <a:off x="1270000" y="10566400"/>
+            <a:ext cx="1066800" cy="1066800"/>
+          </a:xfrm>
+          <a:prstGeom prst="ellipse">
+            <a:avLst/>
+          </a:prstGeom>
+          <a:solidFill>
+            <a:srgbClr val="664092"/>
+          </a:solidFill>
+          <a:ln>
+            <a:noFill/>
+          </a:ln>
+          <a:effectLst/>
+        </p:spPr>
+        <p:txBody>
+          <a:bodyPr rtlCol="0" anchor="ctr"/>
+          <a:lstStyle/>
+          <a:p/>
+        </p:txBody>
+      </p:sp>
+      <p:pic>
+        <p:nvPicPr>
+          <p:cNvPr id="34" name="Picture 33" descr="users-round_w.png"/>
+          <p:cNvPicPr>
+            <a:picLocks noChangeAspect="1"/>
+          </p:cNvPicPr>
+          <p:nvPr/>
+        </p:nvPicPr>
+        <p:blipFill>
+          <a:blip r:embed="rId6"/>
+          <a:stretch>
+            <a:fillRect/>
+          </a:stretch>
+        </p:blipFill>
+        <p:spPr>
+          <a:xfrm>
+            <a:off x="1511300" y="10807700"/>
+            <a:ext cx="584200" cy="584200"/>
+          </a:xfrm>
+          <a:prstGeom prst="rect">
+            <a:avLst/>
+          </a:prstGeom>
+        </p:spPr>
+      </p:pic>
+      <p:sp>
+        <p:nvSpPr>
+          <p:cNvPr id="35" name="TextBox 34"/>
+          <p:cNvSpPr txBox="1"/>
+          <p:nvPr/>
+        </p:nvSpPr>
+        <p:spPr>
+          <a:xfrm>
+            <a:off x="2590800" y="10591800"/>
+            <a:ext cx="6096000" cy="584200"/>
+          </a:xfrm>
+          <a:prstGeom prst="rect">
+            <a:avLst/>
+          </a:prstGeom>
+          <a:noFill/>
+        </p:spPr>
+        <p:txBody>
+          <a:bodyPr wrap="square" lIns="0" rIns="0" tIns="0" bIns="0" anchor="ctr">
+            <a:spAutoFit/>
+          </a:bodyPr>
+          <a:lstStyle/>
+          <a:p>
+            <a:pPr algn="l"/>
+            <a:r>
+              <a:rPr sz="3200" b="1">
+                <a:solidFill>
+                  <a:srgbClr val="664092"/>
+                </a:solidFill>
+                <a:latin typeface="Metropolis"/>
+              </a:rPr>
+              <a:t>Pensamiento de diseño</a:t>
+            </a:r>
+          </a:p>
+        </p:txBody>
+      </p:sp>
+      <p:sp>
+        <p:nvSpPr>
+          <p:cNvPr id="36" name="TextBox 35"/>
+          <p:cNvSpPr txBox="1"/>
+          <p:nvPr/>
+        </p:nvSpPr>
+        <p:spPr>
+          <a:xfrm>
+            <a:off x="2590800" y="11201400"/>
+            <a:ext cx="6096000" cy="381000"/>
+          </a:xfrm>
+          <a:prstGeom prst="rect">
+            <a:avLst/>
+          </a:prstGeom>
+          <a:noFill/>
+        </p:spPr>
+        <p:txBody>
+          <a:bodyPr wrap="square" lIns="0" rIns="0" tIns="0" bIns="0" anchor="ctr">
+            <a:spAutoFit/>
+          </a:bodyPr>
+          <a:lstStyle/>
+          <a:p>
+            <a:pPr algn="l"/>
+            <a:r>
+              <a:rPr sz="1800" b="1">
+                <a:solidFill>
+                  <a:srgbClr val="3D2159"/>
+                </a:solidFill>
+                <a:latin typeface="Metropolis"/>
+              </a:rPr>
+              <a:t>La forma de abordar los problemas</a:t>
+            </a:r>
+          </a:p>
+        </p:txBody>
+      </p:sp>
+      <p:sp>
+        <p:nvSpPr>
+          <p:cNvPr id="37" name="TextBox 36"/>
+          <p:cNvSpPr txBox="1"/>
+          <p:nvPr/>
+        </p:nvSpPr>
+        <p:spPr>
+          <a:xfrm>
+            <a:off x="1270000" y="11861800"/>
+            <a:ext cx="7416800" cy="1143000"/>
+          </a:xfrm>
+          <a:prstGeom prst="rect">
+            <a:avLst/>
+          </a:prstGeom>
+          <a:noFill/>
+        </p:spPr>
+        <p:txBody>
+          <a:bodyPr wrap="square" lIns="0" rIns="0" tIns="0" bIns="0" anchor="t">
+            <a:spAutoFit/>
+          </a:bodyPr>
+          <a:lstStyle/>
+          <a:p>
+            <a:pPr algn="l">
+              <a:lnSpc>
+                <a:spcPct val="118000"/>
+              </a:lnSpc>
+            </a:pPr>
+            <a:r>
+              <a:rPr sz="1700" b="0">
+                <a:solidFill>
+                  <a:srgbClr val="455971"/>
+                </a:solidFill>
+                <a:latin typeface="Metropolis"/>
+              </a:rPr>
+              <a:t>Proceso centrado en las personas que integra empatía, definición, ideación, prototipado y prueba para encontrar soluciones viables, deseables y factibles.</a:t>
+            </a:r>
+          </a:p>
+        </p:txBody>
+      </p:sp>
+      <p:sp>
+        <p:nvSpPr>
+          <p:cNvPr id="38" name="Rounded Rectangle 37"/>
+          <p:cNvSpPr/>
+          <p:nvPr/>
+        </p:nvSpPr>
+        <p:spPr>
+          <a:xfrm>
+            <a:off x="1270000" y="13106400"/>
+            <a:ext cx="7416800" cy="1498600"/>
+          </a:xfrm>
+          <a:prstGeom prst="roundRect">
+            <a:avLst>
+              <a:gd name="adj" fmla="val 9230"/>
+            </a:avLst>
+          </a:prstGeom>
+          <a:solidFill>
+            <a:srgbClr val="F1EBF6"/>
+          </a:solidFill>
+          <a:ln>
+            <a:noFill/>
+          </a:ln>
+          <a:effectLst/>
+        </p:spPr>
+        <p:txBody>
+          <a:bodyPr rtlCol="0" anchor="ctr"/>
+          <a:lstStyle/>
+          <a:p/>
+        </p:txBody>
+      </p:sp>
+      <p:sp>
+        <p:nvSpPr>
+          <p:cNvPr id="39" name="Oval 38"/>
+          <p:cNvSpPr/>
+          <p:nvPr/>
+        </p:nvSpPr>
+        <p:spPr>
+          <a:xfrm>
+            <a:off x="1574800" y="13462000"/>
+            <a:ext cx="139700" cy="139700"/>
+          </a:xfrm>
+          <a:prstGeom prst="ellipse">
+            <a:avLst/>
+          </a:prstGeom>
+          <a:solidFill>
+            <a:srgbClr val="664092"/>
+          </a:solidFill>
+          <a:ln>
+            <a:noFill/>
+          </a:ln>
+          <a:effectLst/>
+        </p:spPr>
+        <p:txBody>
+          <a:bodyPr rtlCol="0" anchor="ctr"/>
+          <a:lstStyle/>
+          <a:p/>
+        </p:txBody>
+      </p:sp>
+      <p:sp>
+        <p:nvSpPr>
+          <p:cNvPr id="40" name="TextBox 39"/>
+          <p:cNvSpPr txBox="1"/>
+          <p:nvPr/>
+        </p:nvSpPr>
+        <p:spPr>
+          <a:xfrm>
+            <a:off x="1879600" y="13347700"/>
+            <a:ext cx="6604000" cy="381000"/>
+          </a:xfrm>
+          <a:prstGeom prst="rect">
+            <a:avLst/>
+          </a:prstGeom>
+          <a:noFill/>
+        </p:spPr>
+        <p:txBody>
+          <a:bodyPr wrap="square" lIns="0" rIns="0" tIns="0" bIns="0" anchor="ctr">
+            <a:spAutoFit/>
+          </a:bodyPr>
+          <a:lstStyle/>
+          <a:p>
+            <a:pPr algn="l"/>
+            <a:r>
+              <a:rPr sz="1600" b="0">
+                <a:solidFill>
+                  <a:srgbClr val="3D2159"/>
+                </a:solidFill>
+                <a:latin typeface="Metropolis"/>
+              </a:rPr>
+              <a:t>Parte de necesidades reales.</a:t>
+            </a:r>
+          </a:p>
+        </p:txBody>
+      </p:sp>
+      <p:sp>
+        <p:nvSpPr>
+          <p:cNvPr id="41" name="Oval 40"/>
+          <p:cNvSpPr/>
+          <p:nvPr/>
+        </p:nvSpPr>
+        <p:spPr>
+          <a:xfrm>
+            <a:off x="1574800" y="13868400"/>
+            <a:ext cx="139700" cy="139700"/>
+          </a:xfrm>
+          <a:prstGeom prst="ellipse">
+            <a:avLst/>
+          </a:prstGeom>
+          <a:solidFill>
+            <a:srgbClr val="664092"/>
+          </a:solidFill>
+          <a:ln>
+            <a:noFill/>
+          </a:ln>
+          <a:effectLst/>
+        </p:spPr>
+        <p:txBody>
+          <a:bodyPr rtlCol="0" anchor="ctr"/>
+          <a:lstStyle/>
+          <a:p/>
+        </p:txBody>
+      </p:sp>
+      <p:sp>
+        <p:nvSpPr>
+          <p:cNvPr id="42" name="TextBox 41"/>
+          <p:cNvSpPr txBox="1"/>
+          <p:nvPr/>
+        </p:nvSpPr>
+        <p:spPr>
+          <a:xfrm>
+            <a:off x="1879600" y="13754100"/>
+            <a:ext cx="6604000" cy="381000"/>
+          </a:xfrm>
+          <a:prstGeom prst="rect">
+            <a:avLst/>
+          </a:prstGeom>
+          <a:noFill/>
+        </p:spPr>
+        <p:txBody>
+          <a:bodyPr wrap="square" lIns="0" rIns="0" tIns="0" bIns="0" anchor="ctr">
+            <a:spAutoFit/>
+          </a:bodyPr>
+          <a:lstStyle/>
+          <a:p>
+            <a:pPr algn="l"/>
+            <a:r>
+              <a:rPr sz="1600" b="0">
+                <a:solidFill>
+                  <a:srgbClr val="3D2159"/>
+                </a:solidFill>
+                <a:latin typeface="Metropolis"/>
+              </a:rPr>
+              <a:t>Combina la creatividad con un proceso estructurado.</a:t>
+            </a:r>
+          </a:p>
+        </p:txBody>
+      </p:sp>
+      <p:sp>
+        <p:nvSpPr>
+          <p:cNvPr id="43" name="Oval 42"/>
+          <p:cNvSpPr/>
+          <p:nvPr/>
+        </p:nvSpPr>
+        <p:spPr>
+          <a:xfrm>
+            <a:off x="1574800" y="14274800"/>
+            <a:ext cx="139700" cy="139700"/>
+          </a:xfrm>
+          <a:prstGeom prst="ellipse">
+            <a:avLst/>
+          </a:prstGeom>
+          <a:solidFill>
+            <a:srgbClr val="664092"/>
+          </a:solidFill>
+          <a:ln>
+            <a:noFill/>
+          </a:ln>
+          <a:effectLst/>
+        </p:spPr>
+        <p:txBody>
+          <a:bodyPr rtlCol="0" anchor="ctr"/>
+          <a:lstStyle/>
+          <a:p/>
+        </p:txBody>
+      </p:sp>
+      <p:sp>
+        <p:nvSpPr>
+          <p:cNvPr id="44" name="TextBox 43"/>
+          <p:cNvSpPr txBox="1"/>
+          <p:nvPr/>
+        </p:nvSpPr>
+        <p:spPr>
+          <a:xfrm>
+            <a:off x="1879600" y="14160500"/>
+            <a:ext cx="6604000" cy="381000"/>
+          </a:xfrm>
+          <a:prstGeom prst="rect">
+            <a:avLst/>
+          </a:prstGeom>
+          <a:noFill/>
+        </p:spPr>
+        <p:txBody>
+          <a:bodyPr wrap="square" lIns="0" rIns="0" tIns="0" bIns="0" anchor="ctr">
+            <a:spAutoFit/>
+          </a:bodyPr>
+          <a:lstStyle/>
+          <a:p>
+            <a:pPr algn="l"/>
+            <a:r>
+              <a:rPr sz="1600" b="0">
+                <a:solidFill>
+                  <a:srgbClr val="3D2159"/>
+                </a:solidFill>
+                <a:latin typeface="Metropolis"/>
+              </a:rPr>
+              <a:t>Valida ideas con las personas usuarias.</a:t>
+            </a:r>
+          </a:p>
+        </p:txBody>
+      </p:sp>
+      <p:sp>
+        <p:nvSpPr>
+          <p:cNvPr id="45" name="Imagen 2 · Pensamiento de diseño — reemplazar con la foto (Relleno con imagen)"/>
+          <p:cNvSpPr/>
+          <p:nvPr/>
+        </p:nvSpPr>
+        <p:spPr>
+          <a:xfrm>
+            <a:off x="9093200" y="10566400"/>
+            <a:ext cx="3454400" cy="3962400"/>
+          </a:xfrm>
+          <a:prstGeom prst="roundRect">
+            <a:avLst>
+              <a:gd name="adj" fmla="val 5925"/>
+            </a:avLst>
+          </a:prstGeom>
+          <a:solidFill>
+            <a:srgbClr val="F1EBF6"/>
+          </a:solidFill>
+          <a:ln>
+            <a:noFill/>
+          </a:ln>
+          <a:effectLst/>
+        </p:spPr>
+        <p:txBody>
+          <a:bodyPr rtlCol="0" anchor="ctr"/>
+          <a:lstStyle/>
+          <a:p/>
+        </p:txBody>
+      </p:sp>
+      <p:sp>
+        <p:nvSpPr>
+          <p:cNvPr id="49" name="Oval 48"/>
+          <p:cNvSpPr/>
+          <p:nvPr/>
+        </p:nvSpPr>
+        <p:spPr>
+          <a:xfrm>
+            <a:off x="6578600" y="14935200"/>
+            <a:ext cx="558800" cy="558800"/>
+          </a:xfrm>
+          <a:prstGeom prst="ellipse">
+            <a:avLst/>
+          </a:prstGeom>
+          <a:solidFill>
+            <a:srgbClr val="FFFFFF"/>
+          </a:solidFill>
+          <a:ln w="31750">
+            <a:solidFill>
+              <a:srgbClr val="2BB3C0"/>
+            </a:solidFill>
+          </a:ln>
+          <a:effectLst/>
+        </p:spPr>
+        <p:txBody>
+          <a:bodyPr rtlCol="0" anchor="ctr"/>
+          <a:lstStyle/>
+          <a:p/>
+        </p:txBody>
+      </p:sp>
+      <p:pic>
+        <p:nvPicPr>
+          <p:cNvPr id="50" name="Picture 49" descr="plus_bl.png"/>
+          <p:cNvPicPr>
+            <a:picLocks noChangeAspect="1"/>
+          </p:cNvPicPr>
+          <p:nvPr/>
+        </p:nvPicPr>
+        <p:blipFill>
+          <a:blip r:embed="rId5"/>
+          <a:stretch>
+            <a:fillRect/>
+          </a:stretch>
+        </p:blipFill>
+        <p:spPr>
+          <a:xfrm>
+            <a:off x="6692900" y="15049500"/>
+            <a:ext cx="330200" cy="330200"/>
+          </a:xfrm>
+          <a:prstGeom prst="rect">
+            <a:avLst/>
+          </a:prstGeom>
+        </p:spPr>
+      </p:pic>
+      <p:sp>
+        <p:nvSpPr>
+          <p:cNvPr id="51" name="Rounded Rectangle 50"/>
+          <p:cNvSpPr/>
+          <p:nvPr/>
+        </p:nvSpPr>
+        <p:spPr>
+          <a:xfrm>
+            <a:off x="762000" y="15519400"/>
+            <a:ext cx="12192000" cy="4724400"/>
+          </a:xfrm>
+          <a:prstGeom prst="roundRect">
+            <a:avLst>
+              <a:gd name="adj" fmla="val 4891"/>
+            </a:avLst>
+          </a:prstGeom>
+          <a:solidFill>
+            <a:srgbClr val="FFFFFF"/>
+          </a:solidFill>
+          <a:ln w="31750">
+            <a:solidFill>
+              <a:srgbClr val="2A56C6"/>
+            </a:solidFill>
+          </a:ln>
+          <a:effectLst/>
+        </p:spPr>
+        <p:txBody>
+          <a:bodyPr rtlCol="0" anchor="ctr"/>
+          <a:lstStyle/>
+          <a:p/>
+        </p:txBody>
+      </p:sp>
+      <p:sp>
+        <p:nvSpPr>
+          <p:cNvPr id="52" name="Rectangle 51"/>
+          <p:cNvSpPr/>
+          <p:nvPr/>
+        </p:nvSpPr>
+        <p:spPr>
+          <a:xfrm>
+            <a:off x="762000" y="15519400"/>
+            <a:ext cx="177800" cy="4724400"/>
+          </a:xfrm>
+          <a:prstGeom prst="rect">
+            <a:avLst/>
+          </a:prstGeom>
+          <a:solidFill>
+            <a:srgbClr val="2A56C6"/>
+          </a:solidFill>
+          <a:ln>
+            <a:noFill/>
+          </a:ln>
+          <a:effectLst/>
+        </p:spPr>
+        <p:txBody>
+          <a:bodyPr rtlCol="0" anchor="ctr"/>
+          <a:lstStyle/>
+          <a:p/>
+        </p:txBody>
+      </p:sp>
+      <p:sp>
+        <p:nvSpPr>
+          <p:cNvPr id="53" name="Oval 52"/>
+          <p:cNvSpPr/>
+          <p:nvPr/>
+        </p:nvSpPr>
+        <p:spPr>
+          <a:xfrm>
+            <a:off x="1270000" y="15900400"/>
+            <a:ext cx="1066800" cy="1066800"/>
+          </a:xfrm>
+          <a:prstGeom prst="ellipse">
+            <a:avLst/>
+          </a:prstGeom>
+          <a:solidFill>
+            <a:srgbClr val="2A56C6"/>
+          </a:solidFill>
+          <a:ln>
+            <a:noFill/>
+          </a:ln>
+          <a:effectLst/>
+        </p:spPr>
+        <p:txBody>
+          <a:bodyPr rtlCol="0" anchor="ctr"/>
+          <a:lstStyle/>
+          <a:p/>
+        </p:txBody>
+      </p:sp>
+      <p:pic>
+        <p:nvPicPr>
+          <p:cNvPr id="54" name="Picture 53" descr="trending-up_w.png"/>
+          <p:cNvPicPr>
+            <a:picLocks noChangeAspect="1"/>
+          </p:cNvPicPr>
+          <p:nvPr/>
+        </p:nvPicPr>
+        <p:blipFill>
+          <a:blip r:embed="rId8"/>
+          <a:stretch>
+            <a:fillRect/>
+          </a:stretch>
+        </p:blipFill>
+        <p:spPr>
+          <a:xfrm>
+            <a:off x="1511300" y="16141700"/>
+            <a:ext cx="584200" cy="584200"/>
+          </a:xfrm>
+          <a:prstGeom prst="rect">
+            <a:avLst/>
+          </a:prstGeom>
+        </p:spPr>
+      </p:pic>
+      <p:sp>
+        <p:nvSpPr>
+          <p:cNvPr id="55" name="TextBox 54"/>
+          <p:cNvSpPr txBox="1"/>
+          <p:nvPr/>
+        </p:nvSpPr>
+        <p:spPr>
+          <a:xfrm>
+            <a:off x="2590800" y="15925800"/>
+            <a:ext cx="6096000" cy="584200"/>
+          </a:xfrm>
+          <a:prstGeom prst="rect">
+            <a:avLst/>
+          </a:prstGeom>
+          <a:noFill/>
+        </p:spPr>
+        <p:txBody>
+          <a:bodyPr wrap="square" lIns="0" rIns="0" tIns="0" bIns="0" anchor="ctr">
+            <a:spAutoFit/>
+          </a:bodyPr>
+          <a:lstStyle/>
+          <a:p>
+            <a:pPr algn="l"/>
+            <a:r>
+              <a:rPr sz="3200" b="1">
+                <a:solidFill>
+                  <a:srgbClr val="2A56C6"/>
+                </a:solidFill>
+                <a:latin typeface="Metropolis"/>
+              </a:rPr>
+              <a:t>Innovación</a:t>
+            </a:r>
+          </a:p>
+        </p:txBody>
+      </p:sp>
+      <p:sp>
+        <p:nvSpPr>
+          <p:cNvPr id="56" name="TextBox 55"/>
+          <p:cNvSpPr txBox="1"/>
+          <p:nvPr/>
+        </p:nvSpPr>
+        <p:spPr>
+          <a:xfrm>
+            <a:off x="2590800" y="16535400"/>
+            <a:ext cx="6096000" cy="381000"/>
+          </a:xfrm>
+          <a:prstGeom prst="rect">
+            <a:avLst/>
+          </a:prstGeom>
+          <a:noFill/>
+        </p:spPr>
+        <p:txBody>
+          <a:bodyPr wrap="square" lIns="0" rIns="0" tIns="0" bIns="0" anchor="ctr">
+            <a:spAutoFit/>
+          </a:bodyPr>
+          <a:lstStyle/>
+          <a:p>
+            <a:pPr algn="l"/>
+            <a:r>
+              <a:rPr sz="1800" b="1">
+                <a:solidFill>
+                  <a:srgbClr val="3D2159"/>
+                </a:solidFill>
+                <a:latin typeface="Metropolis"/>
+              </a:rPr>
+              <a:t>La puesta en práctica con impacto</a:t>
+            </a:r>
+          </a:p>
+        </p:txBody>
+      </p:sp>
+      <p:sp>
+        <p:nvSpPr>
+          <p:cNvPr id="57" name="TextBox 56"/>
+          <p:cNvSpPr txBox="1"/>
+          <p:nvPr/>
+        </p:nvSpPr>
+        <p:spPr>
+          <a:xfrm>
+            <a:off x="1270000" y="17195800"/>
+            <a:ext cx="7416800" cy="1143000"/>
+          </a:xfrm>
+          <a:prstGeom prst="rect">
+            <a:avLst/>
+          </a:prstGeom>
+          <a:noFill/>
+        </p:spPr>
+        <p:txBody>
+          <a:bodyPr wrap="square" lIns="0" rIns="0" tIns="0" bIns="0" anchor="t">
+            <a:spAutoFit/>
+          </a:bodyPr>
+          <a:lstStyle/>
+          <a:p>
+            <a:pPr algn="l">
+              <a:lnSpc>
+                <a:spcPct val="118000"/>
+              </a:lnSpc>
+            </a:pPr>
+            <a:r>
+              <a:rPr sz="1700" b="0">
+                <a:solidFill>
+                  <a:srgbClr val="455971"/>
+                </a:solidFill>
+                <a:latin typeface="Metropolis"/>
+              </a:rPr>
+              <a:t>Implementación de soluciones que generan valor real en contextos específicos, con mejoras tangibles en la vida de las personas y las organizaciones.</a:t>
+            </a:r>
+          </a:p>
+        </p:txBody>
+      </p:sp>
+      <p:sp>
+        <p:nvSpPr>
+          <p:cNvPr id="58" name="Rounded Rectangle 57"/>
+          <p:cNvSpPr/>
+          <p:nvPr/>
+        </p:nvSpPr>
+        <p:spPr>
+          <a:xfrm>
+            <a:off x="1270000" y="18440400"/>
+            <a:ext cx="7416800" cy="1498600"/>
+          </a:xfrm>
+          <a:prstGeom prst="roundRect">
+            <a:avLst>
+              <a:gd name="adj" fmla="val 9230"/>
+            </a:avLst>
+          </a:prstGeom>
+          <a:solidFill>
+            <a:srgbClr val="E8F1FB"/>
+          </a:solidFill>
+          <a:ln>
+            <a:noFill/>
+          </a:ln>
+          <a:effectLst/>
+        </p:spPr>
+        <p:txBody>
+          <a:bodyPr rtlCol="0" anchor="ctr"/>
+          <a:lstStyle/>
+          <a:p/>
+        </p:txBody>
+      </p:sp>
+      <p:sp>
+        <p:nvSpPr>
+          <p:cNvPr id="59" name="Oval 58"/>
+          <p:cNvSpPr/>
+          <p:nvPr/>
+        </p:nvSpPr>
+        <p:spPr>
+          <a:xfrm>
+            <a:off x="1574800" y="18796000"/>
+            <a:ext cx="139700" cy="139700"/>
+          </a:xfrm>
+          <a:prstGeom prst="ellipse">
+            <a:avLst/>
+          </a:prstGeom>
+          <a:solidFill>
+            <a:srgbClr val="2A56C6"/>
+          </a:solidFill>
+          <a:ln>
+            <a:noFill/>
+          </a:ln>
+          <a:effectLst/>
+        </p:spPr>
+        <p:txBody>
+          <a:bodyPr rtlCol="0" anchor="ctr"/>
+          <a:lstStyle/>
+          <a:p/>
+        </p:txBody>
+      </p:sp>
+      <p:sp>
+        <p:nvSpPr>
+          <p:cNvPr id="60" name="TextBox 59"/>
+          <p:cNvSpPr txBox="1"/>
+          <p:nvPr/>
+        </p:nvSpPr>
+        <p:spPr>
+          <a:xfrm>
+            <a:off x="1879600" y="18681700"/>
+            <a:ext cx="6604000" cy="381000"/>
+          </a:xfrm>
+          <a:prstGeom prst="rect">
+            <a:avLst/>
+          </a:prstGeom>
+          <a:noFill/>
+        </p:spPr>
+        <p:txBody>
+          <a:bodyPr wrap="square" lIns="0" rIns="0" tIns="0" bIns="0" anchor="ctr">
+            <a:spAutoFit/>
+          </a:bodyPr>
+          <a:lstStyle/>
+          <a:p>
+            <a:pPr algn="l"/>
+            <a:r>
+              <a:rPr sz="1600" b="0">
+                <a:solidFill>
+                  <a:srgbClr val="3D2159"/>
+                </a:solidFill>
+                <a:latin typeface="Metropolis"/>
+              </a:rPr>
+              <a:t>Convierte ideas en resultados.</a:t>
+            </a:r>
+          </a:p>
+        </p:txBody>
+      </p:sp>
+      <p:sp>
+        <p:nvSpPr>
+          <p:cNvPr id="61" name="Oval 60"/>
+          <p:cNvSpPr/>
+          <p:nvPr/>
+        </p:nvSpPr>
+        <p:spPr>
+          <a:xfrm>
+            <a:off x="1574800" y="19202400"/>
+            <a:ext cx="139700" cy="139700"/>
+          </a:xfrm>
+          <a:prstGeom prst="ellipse">
+            <a:avLst/>
+          </a:prstGeom>
+          <a:solidFill>
+            <a:srgbClr val="2A56C6"/>
+          </a:solidFill>
+          <a:ln>
+            <a:noFill/>
+          </a:ln>
+          <a:effectLst/>
+        </p:spPr>
+        <p:txBody>
+          <a:bodyPr rtlCol="0" anchor="ctr"/>
+          <a:lstStyle/>
+          <a:p/>
+        </p:txBody>
+      </p:sp>
+      <p:sp>
+        <p:nvSpPr>
+          <p:cNvPr id="62" name="TextBox 61"/>
+          <p:cNvSpPr txBox="1"/>
+          <p:nvPr/>
+        </p:nvSpPr>
+        <p:spPr>
+          <a:xfrm>
+            <a:off x="1879600" y="19088100"/>
+            <a:ext cx="6604000" cy="381000"/>
+          </a:xfrm>
+          <a:prstGeom prst="rect">
+            <a:avLst/>
+          </a:prstGeom>
+          <a:noFill/>
+        </p:spPr>
+        <p:txBody>
+          <a:bodyPr wrap="square" lIns="0" rIns="0" tIns="0" bIns="0" anchor="ctr">
+            <a:spAutoFit/>
+          </a:bodyPr>
+          <a:lstStyle/>
+          <a:p>
+            <a:pPr algn="l"/>
+            <a:r>
+              <a:rPr sz="1600" b="0">
+                <a:solidFill>
+                  <a:srgbClr val="3D2159"/>
+                </a:solidFill>
+                <a:latin typeface="Metropolis"/>
+              </a:rPr>
+              <a:t>Genera valor social, económico o ambiental.</a:t>
+            </a:r>
+          </a:p>
+        </p:txBody>
+      </p:sp>
+      <p:sp>
+        <p:nvSpPr>
+          <p:cNvPr id="63" name="Oval 62"/>
+          <p:cNvSpPr/>
+          <p:nvPr/>
+        </p:nvSpPr>
+        <p:spPr>
+          <a:xfrm>
+            <a:off x="1574800" y="19608800"/>
+            <a:ext cx="139700" cy="139700"/>
+          </a:xfrm>
+          <a:prstGeom prst="ellipse">
+            <a:avLst/>
+          </a:prstGeom>
+          <a:solidFill>
+            <a:srgbClr val="2A56C6"/>
+          </a:solidFill>
+          <a:ln>
+            <a:noFill/>
+          </a:ln>
+          <a:effectLst/>
+        </p:spPr>
+        <p:txBody>
+          <a:bodyPr rtlCol="0" anchor="ctr"/>
+          <a:lstStyle/>
+          <a:p/>
+        </p:txBody>
+      </p:sp>
+      <p:sp>
+        <p:nvSpPr>
+          <p:cNvPr id="64" name="TextBox 63"/>
+          <p:cNvSpPr txBox="1"/>
+          <p:nvPr/>
+        </p:nvSpPr>
+        <p:spPr>
+          <a:xfrm>
+            <a:off x="1879600" y="19494500"/>
+            <a:ext cx="6604000" cy="381000"/>
+          </a:xfrm>
+          <a:prstGeom prst="rect">
+            <a:avLst/>
+          </a:prstGeom>
+          <a:noFill/>
+        </p:spPr>
+        <p:txBody>
+          <a:bodyPr wrap="square" lIns="0" rIns="0" tIns="0" bIns="0" anchor="ctr">
+            <a:spAutoFit/>
+          </a:bodyPr>
+          <a:lstStyle/>
+          <a:p>
+            <a:pPr algn="l"/>
+            <a:r>
+              <a:rPr sz="1600" b="0">
+                <a:solidFill>
+                  <a:srgbClr val="3D2159"/>
+                </a:solidFill>
+                <a:latin typeface="Metropolis"/>
+              </a:rPr>
+              <a:t>Implica apropiación, sostenibilidad y escala.</a:t>
+            </a:r>
+          </a:p>
+        </p:txBody>
+      </p:sp>
+      <p:sp>
+        <p:nvSpPr>
+          <p:cNvPr id="65" name="Imagen 3 · Innovación — reemplazar con la foto (Relleno con imagen)"/>
+          <p:cNvSpPr/>
+          <p:nvPr/>
+        </p:nvSpPr>
+        <p:spPr>
+          <a:xfrm>
+            <a:off x="9093200" y="15900400"/>
+            <a:ext cx="3454400" cy="3962400"/>
+          </a:xfrm>
+          <a:prstGeom prst="roundRect">
+            <a:avLst>
+              <a:gd name="adj" fmla="val 5925"/>
+            </a:avLst>
+          </a:prstGeom>
+          <a:solidFill>
+            <a:srgbClr val="E8F1FB"/>
+          </a:solidFill>
+          <a:ln>
+            <a:noFill/>
+          </a:ln>
+          <a:effectLst/>
+        </p:spPr>
+        <p:txBody>
+          <a:bodyPr rtlCol="0" anchor="ctr"/>
+          <a:lstStyle/>
+          <a:p/>
+        </p:txBody>
+      </p:sp>
+      <p:sp>
+        <p:nvSpPr>
+          <p:cNvPr id="69" name="Rounded Rectangle 68"/>
+          <p:cNvSpPr/>
+          <p:nvPr/>
+        </p:nvSpPr>
+        <p:spPr>
+          <a:xfrm>
+            <a:off x="762000" y="20701000"/>
+            <a:ext cx="12192000" cy="1778000"/>
+          </a:xfrm>
+          <a:prstGeom prst="roundRect">
+            <a:avLst>
+              <a:gd name="adj" fmla="val 13432"/>
+            </a:avLst>
+          </a:prstGeom>
+          <a:gradFill rotWithShape="1">
+            <a:gsLst>
+              <a:gs pos="0">
+                <a:srgbClr val="4B1E78"/>
+              </a:gs>
+              <a:gs pos="100000">
+                <a:srgbClr val="2A56C6"/>
+              </a:gs>
+            </a:gsLst>
+            <a:lin ang="0" scaled="0"/>
+          </a:gradFill>
+          <a:ln>
+            <a:noFill/>
+          </a:ln>
+          <a:effectLst/>
+        </p:spPr>
+        <p:txBody>
+          <a:bodyPr rtlCol="0" anchor="ctr"/>
+          <a:lstStyle/>
+          <a:p/>
+        </p:txBody>
+      </p:sp>
+      <p:sp>
+        <p:nvSpPr>
+          <p:cNvPr id="70" name="Oval 69"/>
+          <p:cNvSpPr/>
+          <p:nvPr/>
+        </p:nvSpPr>
+        <p:spPr>
+          <a:xfrm>
+            <a:off x="1219200" y="21082000"/>
+            <a:ext cx="1016000" cy="1016000"/>
+          </a:xfrm>
+          <a:prstGeom prst="ellipse">
+            <a:avLst/>
+          </a:prstGeom>
+          <a:solidFill>
+            <a:srgbClr val="FFD900"/>
+          </a:solidFill>
+          <a:ln>
+            <a:noFill/>
+          </a:ln>
+          <a:effectLst/>
+        </p:spPr>
+        <p:txBody>
+          <a:bodyPr rtlCol="0" anchor="ctr"/>
+          <a:lstStyle/>
+          <a:p/>
+        </p:txBody>
+      </p:sp>
+      <p:pic>
+        <p:nvPicPr>
+          <p:cNvPr id="71" name="Picture 70" descr="target_dk.png"/>
+          <p:cNvPicPr>
+            <a:picLocks noChangeAspect="1"/>
+          </p:cNvPicPr>
+          <p:nvPr/>
+        </p:nvPicPr>
+        <p:blipFill>
+          <a:blip r:embed="rId10"/>
+          <a:stretch>
+            <a:fillRect/>
+          </a:stretch>
+        </p:blipFill>
+        <p:spPr>
+          <a:xfrm>
+            <a:off x="1447800" y="21310600"/>
+            <a:ext cx="558800" cy="558800"/>
+          </a:xfrm>
+          <a:prstGeom prst="rect">
+            <a:avLst/>
+          </a:prstGeom>
+        </p:spPr>
+      </p:pic>
+      <p:sp>
+        <p:nvSpPr>
+          <p:cNvPr id="72" name="Rounded Rectangle 71"/>
+          <p:cNvSpPr/>
+          <p:nvPr/>
+        </p:nvSpPr>
+        <p:spPr>
+          <a:xfrm>
+            <a:off x="2616200" y="20980400"/>
+            <a:ext cx="3175000" cy="431800"/>
+          </a:xfrm>
+          <a:prstGeom prst="roundRect">
+            <a:avLst>
+              <a:gd name="adj" fmla="val 50000"/>
+            </a:avLst>
+          </a:prstGeom>
+          <a:solidFill>
+            <a:srgbClr val="FFD900"/>
+          </a:solidFill>
+          <a:ln>
+            <a:noFill/>
+          </a:ln>
+          <a:effectLst/>
+        </p:spPr>
+        <p:txBody>
+          <a:bodyPr rtlCol="0" anchor="ctr"/>
+          <a:lstStyle/>
+          <a:p/>
+        </p:txBody>
+      </p:sp>
+      <p:sp>
+        <p:nvSpPr>
+          <p:cNvPr id="73" name="TextBox 72"/>
+          <p:cNvSpPr txBox="1"/>
+          <p:nvPr/>
+        </p:nvSpPr>
+        <p:spPr>
+          <a:xfrm>
+            <a:off x="2616200" y="20980400"/>
+            <a:ext cx="3175000" cy="431800"/>
+          </a:xfrm>
+          <a:prstGeom prst="rect">
+            <a:avLst/>
+          </a:prstGeom>
+          <a:noFill/>
+        </p:spPr>
+        <p:txBody>
+          <a:bodyPr wrap="square" lIns="0" rIns="0" tIns="0" bIns="0" anchor="ctr">
+            <a:spAutoFit/>
+          </a:bodyPr>
+          <a:lstStyle/>
+          <a:p>
+            <a:pPr algn="ctr"/>
+            <a:r>
+              <a:rPr sz="1400" b="1">
+                <a:solidFill>
+                  <a:srgbClr val="3D2159"/>
+                </a:solidFill>
+                <a:latin typeface="Metropolis"/>
+              </a:rPr>
+              <a:t>UN MISMO PROPÓSITO</a:t>
+            </a:r>
+          </a:p>
+        </p:txBody>
+      </p:sp>
+      <p:sp>
+        <p:nvSpPr>
+          <p:cNvPr id="74" name="TextBox 73"/>
+          <p:cNvSpPr txBox="1"/>
+          <p:nvPr/>
+        </p:nvSpPr>
+        <p:spPr>
+          <a:xfrm>
+            <a:off x="2616200" y="21513800"/>
+            <a:ext cx="9906000" cy="762000"/>
+          </a:xfrm>
+          <a:prstGeom prst="rect">
+            <a:avLst/>
+          </a:prstGeom>
+          <a:noFill/>
+        </p:spPr>
+        <p:txBody>
+          <a:bodyPr wrap="square" lIns="0" rIns="0" tIns="0" bIns="0" anchor="ctr">
+            <a:spAutoFit/>
+          </a:bodyPr>
+          <a:lstStyle/>
+          <a:p>
+            <a:pPr algn="l">
+              <a:lnSpc>
+                <a:spcPct val="108000"/>
+              </a:lnSpc>
+            </a:pPr>
+            <a:r>
+              <a:rPr sz="1900" b="1">
+                <a:solidFill>
+                  <a:srgbClr val="FFFFFF"/>
+                </a:solidFill>
+                <a:latin typeface="Metropolis"/>
+              </a:rPr>
+              <a:t>Generar soluciones con sentido, </a:t>
+            </a:r>
+            <a:r>
+              <a:rPr sz="1900" b="0">
+                <a:solidFill>
+                  <a:srgbClr val="FFFFFF"/>
+                </a:solidFill>
+                <a:latin typeface="Metropolis"/>
+              </a:rPr>
+              <a:t>que respondan a necesidades reales y mejoren la vida de las personas.</a:t>
+            </a:r>
+          </a:p>
+        </p:txBody>
+      </p:sp>
+      <p:sp>
+        <p:nvSpPr>
+          <p:cNvPr id="75" name="TextBox 74"/>
+          <p:cNvSpPr txBox="1"/>
+          <p:nvPr/>
+        </p:nvSpPr>
+        <p:spPr>
+          <a:xfrm>
+            <a:off x="2286000" y="23342600"/>
+            <a:ext cx="5461000" cy="711200"/>
+          </a:xfrm>
+          <a:prstGeom prst="rect">
+            <a:avLst/>
+          </a:prstGeom>
+          <a:noFill/>
+        </p:spPr>
+        <p:txBody>
+          <a:bodyPr wrap="square" lIns="0" rIns="0" tIns="0" bIns="0" anchor="ctr">
+            <a:spAutoFit/>
+          </a:bodyPr>
+          <a:lstStyle/>
+          <a:p>
+            <a:pPr algn="l">
+              <a:lnSpc>
+                <a:spcPct val="110000"/>
+              </a:lnSpc>
+            </a:pPr>
+            <a:r>
+              <a:rPr sz="1200" b="1">
+                <a:solidFill>
+                  <a:srgbClr val="044992"/>
+                </a:solidFill>
+                <a:latin typeface="Metropolis"/>
+              </a:rPr>
+              <a:t>Nota. </a:t>
+            </a:r>
+            <a:r>
+              <a:rPr sz="1200" b="0">
+                <a:solidFill>
+                  <a:srgbClr val="044992"/>
+                </a:solidFill>
+                <a:latin typeface="Metropolis"/>
+              </a:rPr>
+              <a:t>Elaboración propia con base en Brown (2008), IDEO.org (2015) y Hasso Plattner Institute of Design at Stanford (s. f.).</a:t>
+            </a:r>
+          </a:p>
+        </p:txBody>
+      </p:sp>
+      <p:pic>
+        <p:nvPicPr>
+          <p:cNvPr id="76" name="Picture 75" descr="logos.png"/>
+          <p:cNvPicPr>
+            <a:picLocks noChangeAspect="1"/>
+          </p:cNvPicPr>
+          <p:nvPr/>
+        </p:nvPicPr>
+        <p:blipFill>
+          <a:blip r:embed="rId11"/>
+          <a:stretch>
+            <a:fillRect/>
+          </a:stretch>
+        </p:blipFill>
+        <p:spPr>
+          <a:xfrm>
+            <a:off x="8128000" y="23291800"/>
+            <a:ext cx="4826000" cy="812800"/>
+          </a:xfrm>
+          <a:prstGeom prst="rect">
+            <a:avLst/>
+          </a:prstGeom>
+        </p:spPr>
+      </p:pic>
+      <p:pic>
+        <p:nvPicPr>
+          <p:cNvPr id="77" name="Picture 76" descr="">
+            <a:extLst>
+              <a:ext uri="{C183D7F6-B498-43B3-948B-1728B52AA6E4}">
+                <adec:decorative xmlns:adec="http://schemas.microsoft.com/office/drawing/2017/decorative" val="1"/>
+              </a:ext>
+            </a:extLst>
+          </p:cNvPr>
+          <p:cNvPicPr>
+            <a:picLocks noChangeAspect="1"/>
+          </p:cNvPicPr>
+          <p:nvPr/>
+        </p:nvPicPr>
+        <p:blipFill>
+          <a:blip r:embed="rId12"/>
+          <a:stretch>
+            <a:fillRect/>
+          </a:stretch>
+        </p:blipFill>
+        <p:spPr>
+          <a:xfrm>
+            <a:off x="10248900" y="5537200"/>
+            <a:ext cx="1143000" cy="1143000"/>
+          </a:xfrm>
+          <a:prstGeom prst="rect">
+            <a:avLst/>
+          </a:prstGeom>
+        </p:spPr>
+      </p:pic>
+      <p:sp>
+        <p:nvSpPr>
+          <p:cNvPr id="78" name="Rounded Rectangle 77" descr="">
+            <a:extLst>
+              <a:ext uri="{C183D7F6-B498-43B3-948B-1728B52AA6E4}">
+                <adec:decorative xmlns:adec="http://schemas.microsoft.com/office/drawing/2017/decorative" val="1"/>
+              </a:ext>
+            </a:extLst>
+          </p:cNvPr>
+          <p:cNvSpPr/>
+          <p:nvPr/>
+        </p:nvSpPr>
+        <p:spPr>
+          <a:xfrm>
+            <a:off x="9321800" y="6985000"/>
+            <a:ext cx="2997200" cy="1524000"/>
+          </a:xfrm>
+          <a:prstGeom prst="roundRect">
+            <a:avLst>
+              <a:gd name="adj" fmla="val 16000"/>
+            </a:avLst>
+          </a:prstGeom>
+          <a:solidFill>
+            <a:srgbClr val="FFFFFF"/>
+          </a:solidFill>
+          <a:ln w="19050">
+            <a:solidFill>
+              <a:srgbClr val="F2C200"/>
+            </a:solidFill>
+          </a:ln>
+          <a:effectLst/>
+        </p:spPr>
+        <p:txBody>
+          <a:bodyPr rtlCol="0" anchor="ctr"/>
+          <a:lstStyle/>
+          <a:p>
+            <a:pPr algn="ctr"/>
+          </a:p>
+        </p:txBody>
+      </p:sp>
       <p:pic>
         <p:nvPicPr>
           <p:cNvPr id="26" name="Picture 25" descr="quote_dk.png"/>
@@ -3902,8 +5295,8 @@
         </p:blipFill>
         <p:spPr>
           <a:xfrm>
-            <a:off x="9525000" y="5257800"/>
-            <a:ext cx="558800" cy="558800"/>
+            <a:off x="9601200" y="7213600"/>
+            <a:ext cx="355600" cy="355600"/>
           </a:xfrm>
           <a:prstGeom prst="rect">
             <a:avLst/>
@@ -3912,14 +5305,14 @@
       </p:pic>
       <p:sp>
         <p:nvSpPr>
-          <p:cNvPr id="27" name="TextBox 26"/>
+          <p:cNvPr id="79" name="TextBox 78"/>
           <p:cNvSpPr txBox="1"/>
           <p:nvPr/>
         </p:nvSpPr>
         <p:spPr>
           <a:xfrm>
-            <a:off x="9525000" y="5969000"/>
-            <a:ext cx="2794000" cy="330200"/>
+            <a:off x="9601200" y="7645400"/>
+            <a:ext cx="2489200" cy="762000"/>
           </a:xfrm>
           <a:prstGeom prst="rect">
             <a:avLst/>
@@ -3932,106 +5325,47 @@
           </a:bodyPr>
           <a:lstStyle/>
           <a:p>
-            <a:pPr algn="l"/>
-            <a:r>
-              <a:rPr sz="1300" b="1">
+            <a:pPr algn="l">
+              <a:lnSpc>
+                <a:spcPct val="105000"/>
+              </a:lnSpc>
+            </a:pPr>
+            <a:r>
+              <a:rPr sz="1800" b="1" i="0">
                 <a:solidFill>
                   <a:srgbClr val="8A6D00"/>
                 </a:solidFill>
-                <a:latin typeface="Metropolis"/>
-              </a:rPr>
-              <a:t>IDEA CLAVE</a:t>
-            </a:r>
-          </a:p>
-        </p:txBody>
-      </p:sp>
-      <p:sp>
-        <p:nvSpPr>
-          <p:cNvPr id="28" name="TextBox 27"/>
-          <p:cNvSpPr txBox="1"/>
-          <p:nvPr/>
-        </p:nvSpPr>
-        <p:spPr>
-          <a:xfrm>
-            <a:off x="9525000" y="6375400"/>
-            <a:ext cx="2819400" cy="1905000"/>
-          </a:xfrm>
-          <a:prstGeom prst="rect">
-            <a:avLst/>
-          </a:prstGeom>
-          <a:noFill/>
-        </p:spPr>
-        <p:txBody>
-          <a:bodyPr wrap="square" lIns="0" rIns="0" tIns="0" bIns="0" anchor="t">
-            <a:spAutoFit/>
-          </a:bodyPr>
-          <a:lstStyle/>
-          <a:p>
-            <a:pPr algn="l">
-              <a:lnSpc>
-                <a:spcPct val="108000"/>
-              </a:lnSpc>
-            </a:pPr>
-            <a:r>
-              <a:rPr sz="2200" b="1">
-                <a:solidFill>
-                  <a:srgbClr val="3D2159"/>
-                </a:solidFill>
-                <a:latin typeface="Metropolis"/>
+                <a:latin typeface="Arial"/>
               </a:rPr>
               <a:t>«Imaginar lo que podría ser»</a:t>
             </a:r>
           </a:p>
         </p:txBody>
       </p:sp>
-      <p:sp>
-        <p:nvSpPr>
-          <p:cNvPr id="29" name="Oval 28"/>
-          <p:cNvSpPr/>
-          <p:nvPr/>
-        </p:nvSpPr>
-        <p:spPr>
-          <a:xfrm>
-            <a:off x="6578600" y="9029700"/>
-            <a:ext cx="558800" cy="558800"/>
-          </a:xfrm>
-          <a:prstGeom prst="ellipse">
-            <a:avLst/>
-          </a:prstGeom>
-          <a:solidFill>
-            <a:srgbClr val="FFFFFF"/>
-          </a:solidFill>
-          <a:ln w="25400">
-            <a:solidFill>
-              <a:srgbClr val="4E6AD5"/>
-            </a:solidFill>
-          </a:ln>
-          <a:effectLst/>
-        </p:spPr>
-        <p:txBody>
-          <a:bodyPr rtlCol="0" anchor="ctr"/>
-          <a:lstStyle/>
-          <a:p/>
-        </p:txBody>
-      </p:sp>
       <p:pic>
         <p:nvPicPr>
-          <p:cNvPr id="30" name="Picture 29" descr="plus_bl.png"/>
+          <p:cNvPr id="80" name="Picture 79" descr="">
+            <a:extLst>
+              <a:ext uri="{C183D7F6-B498-43B3-948B-1728B52AA6E4}">
+                <adec:decorative xmlns:adec="http://schemas.microsoft.com/office/drawing/2017/decorative" val="1"/>
+              </a:ext>
+            </a:extLst>
+          </p:cNvPr>
           <p:cNvPicPr>
             <a:picLocks noChangeAspect="1"/>
           </p:cNvPicPr>
           <p:nvPr/>
         </p:nvPicPr>
         <p:blipFill>
-          <a:blip r:embed="rId5"/>
+          <a:blip r:embed="rId13"/>
           <a:stretch>
             <a:fillRect/>
           </a:stretch>
         </p:blipFill>
         <p:spPr>
           <a:xfrm>
-            <a:off x="6692900" y="9144000"/>
-            <a:ext cx="330200" cy="330200"/>
+            <a:off x="10248900" y="10871200"/>
+            <a:ext cx="1143000" cy="1143000"/>
           </a:xfrm>
           <a:prstGeom prst="rect">
             <a:avLst/>
@@ -4040,24 +5374,30 @@
       </p:pic>
       <p:sp>
         <p:nvSpPr>
-          <p:cNvPr id="31" name="Rounded Rectangle 30"/>
+          <p:cNvPr id="81" name="Rounded Rectangle 80" descr="">
+            <a:extLst>
+              <a:ext uri="{C183D7F6-B498-43B3-948B-1728B52AA6E4}">
+                <adec:decorative xmlns:adec="http://schemas.microsoft.com/office/drawing/2017/decorative" val="1"/>
+              </a:ext>
+            </a:extLst>
+          </p:cNvPr>
           <p:cNvSpPr/>
           <p:nvPr/>
         </p:nvSpPr>
         <p:spPr>
           <a:xfrm>
-            <a:off x="762000" y="9626600"/>
-            <a:ext cx="12192000" cy="4673600"/>
+            <a:off x="9321800" y="12319000"/>
+            <a:ext cx="2997200" cy="1524000"/>
           </a:xfrm>
           <a:prstGeom prst="roundRect">
             <a:avLst>
-              <a:gd name="adj" fmla="val 4891"/>
+              <a:gd name="adj" fmla="val 16000"/>
             </a:avLst>
           </a:prstGeom>
           <a:solidFill>
             <a:srgbClr val="FFFFFF"/>
           </a:solidFill>
-          <a:ln w="28575">
+          <a:ln w="19050">
             <a:solidFill>
               <a:srgbClr val="664092"/>
             </a:solidFill>
@@ -4067,445 +5407,9 @@
         <p:txBody>
           <a:bodyPr rtlCol="0" anchor="ctr"/>
           <a:lstStyle/>
-          <a:p/>
-        </p:txBody>
-      </p:sp>
-      <p:sp>
-        <p:nvSpPr>
-          <p:cNvPr id="32" name="Rectangle 31"/>
-          <p:cNvSpPr/>
-          <p:nvPr/>
-        </p:nvSpPr>
-        <p:spPr>
-          <a:xfrm>
-            <a:off x="762000" y="9626600"/>
-            <a:ext cx="177800" cy="4673600"/>
-          </a:xfrm>
-          <a:prstGeom prst="rect">
-            <a:avLst/>
-          </a:prstGeom>
-          <a:solidFill>
-            <a:srgbClr val="664092"/>
-          </a:solidFill>
-          <a:ln>
-            <a:noFill/>
-          </a:ln>
-          <a:effectLst/>
-        </p:spPr>
-        <p:txBody>
-          <a:bodyPr rtlCol="0" anchor="ctr"/>
-          <a:lstStyle/>
-          <a:p/>
-        </p:txBody>
-      </p:sp>
-      <p:sp>
-        <p:nvSpPr>
-          <p:cNvPr id="33" name="Oval 32"/>
-          <p:cNvSpPr/>
-          <p:nvPr/>
-        </p:nvSpPr>
-        <p:spPr>
-          <a:xfrm>
-            <a:off x="1244600" y="9956800"/>
-            <a:ext cx="1066800" cy="1066800"/>
-          </a:xfrm>
-          <a:prstGeom prst="ellipse">
-            <a:avLst/>
-          </a:prstGeom>
-          <a:solidFill>
-            <a:srgbClr val="664092"/>
-          </a:solidFill>
-          <a:ln>
-            <a:noFill/>
-          </a:ln>
-          <a:effectLst/>
-        </p:spPr>
-        <p:txBody>
-          <a:bodyPr rtlCol="0" anchor="ctr"/>
-          <a:lstStyle/>
-          <a:p/>
-        </p:txBody>
-      </p:sp>
-      <p:pic>
-        <p:nvPicPr>
-          <p:cNvPr id="34" name="Picture 33" descr="users-round_w.png"/>
-          <p:cNvPicPr>
-            <a:picLocks noChangeAspect="1"/>
-          </p:cNvPicPr>
-          <p:nvPr/>
-        </p:nvPicPr>
-        <p:blipFill>
-          <a:blip r:embed="rId6"/>
-          <a:stretch>
-            <a:fillRect/>
-          </a:stretch>
-        </p:blipFill>
-        <p:spPr>
-          <a:xfrm>
-            <a:off x="1485900" y="10198100"/>
-            <a:ext cx="584200" cy="584200"/>
-          </a:xfrm>
-          <a:prstGeom prst="rect">
-            <a:avLst/>
-          </a:prstGeom>
-        </p:spPr>
-      </p:pic>
-      <p:sp>
-        <p:nvSpPr>
-          <p:cNvPr id="35" name="TextBox 34"/>
-          <p:cNvSpPr txBox="1"/>
-          <p:nvPr/>
-        </p:nvSpPr>
-        <p:spPr>
-          <a:xfrm>
-            <a:off x="2540000" y="9982200"/>
-            <a:ext cx="6350000" cy="584200"/>
-          </a:xfrm>
-          <a:prstGeom prst="rect">
-            <a:avLst/>
-          </a:prstGeom>
-          <a:noFill/>
-        </p:spPr>
-        <p:txBody>
-          <a:bodyPr wrap="square" lIns="0" rIns="0" tIns="0" bIns="0" anchor="ctr">
-            <a:spAutoFit/>
-          </a:bodyPr>
-          <a:lstStyle/>
-          <a:p>
-            <a:pPr algn="l"/>
-            <a:r>
-              <a:rPr sz="3200" b="1">
-                <a:solidFill>
-                  <a:srgbClr val="664092"/>
-                </a:solidFill>
-                <a:latin typeface="Metropolis"/>
-              </a:rPr>
-              <a:t>Pensamiento de diseño</a:t>
-            </a:r>
-          </a:p>
-        </p:txBody>
-      </p:sp>
-      <p:sp>
-        <p:nvSpPr>
-          <p:cNvPr id="36" name="TextBox 35"/>
-          <p:cNvSpPr txBox="1"/>
-          <p:nvPr/>
-        </p:nvSpPr>
-        <p:spPr>
-          <a:xfrm>
-            <a:off x="2540000" y="10591800"/>
-            <a:ext cx="6350000" cy="381000"/>
-          </a:xfrm>
-          <a:prstGeom prst="rect">
-            <a:avLst/>
-          </a:prstGeom>
-          <a:noFill/>
-        </p:spPr>
-        <p:txBody>
-          <a:bodyPr wrap="square" lIns="0" rIns="0" tIns="0" bIns="0" anchor="ctr">
-            <a:spAutoFit/>
-          </a:bodyPr>
-          <a:lstStyle/>
-          <a:p>
-            <a:pPr algn="l"/>
-            <a:r>
-              <a:rPr sz="1800" b="1">
-                <a:solidFill>
-                  <a:srgbClr val="3D2159"/>
-                </a:solidFill>
-                <a:latin typeface="Metropolis"/>
-              </a:rPr>
-              <a:t>La forma de abordar los problemas</a:t>
-            </a:r>
-          </a:p>
-        </p:txBody>
-      </p:sp>
-      <p:sp>
-        <p:nvSpPr>
-          <p:cNvPr id="37" name="TextBox 36"/>
-          <p:cNvSpPr txBox="1"/>
-          <p:nvPr/>
-        </p:nvSpPr>
-        <p:spPr>
-          <a:xfrm>
-            <a:off x="1244600" y="11252200"/>
-            <a:ext cx="7620000" cy="1066800"/>
-          </a:xfrm>
-          <a:prstGeom prst="rect">
-            <a:avLst/>
-          </a:prstGeom>
-          <a:noFill/>
-        </p:spPr>
-        <p:txBody>
-          <a:bodyPr wrap="square" lIns="0" rIns="0" tIns="0" bIns="0" anchor="t">
-            <a:spAutoFit/>
-          </a:bodyPr>
-          <a:lstStyle/>
-          <a:p>
-            <a:pPr algn="l">
-              <a:lnSpc>
-                <a:spcPct val="112000"/>
-              </a:lnSpc>
-            </a:pPr>
-            <a:r>
-              <a:rPr sz="1600" b="0">
-                <a:solidFill>
-                  <a:srgbClr val="455971"/>
-                </a:solidFill>
-                <a:latin typeface="Metropolis"/>
-              </a:rPr>
-              <a:t>Proceso centrado en las personas que integra empatía, definición, ideación, prototipado y prueba para encontrar soluciones viables, deseables y factibles.</a:t>
-            </a:r>
-          </a:p>
-        </p:txBody>
-      </p:sp>
-      <p:sp>
-        <p:nvSpPr>
-          <p:cNvPr id="38" name="Rounded Rectangle 37"/>
-          <p:cNvSpPr/>
-          <p:nvPr/>
-        </p:nvSpPr>
-        <p:spPr>
-          <a:xfrm>
-            <a:off x="1244600" y="12293600"/>
-            <a:ext cx="7620000" cy="1651000"/>
-          </a:xfrm>
-          <a:prstGeom prst="roundRect">
-            <a:avLst>
-              <a:gd name="adj" fmla="val 9230"/>
-            </a:avLst>
-          </a:prstGeom>
-          <a:solidFill>
-            <a:srgbClr val="F1EBF6"/>
-          </a:solidFill>
-          <a:ln>
-            <a:noFill/>
-          </a:ln>
-          <a:effectLst/>
-        </p:spPr>
-        <p:txBody>
-          <a:bodyPr rtlCol="0" anchor="ctr"/>
-          <a:lstStyle/>
-          <a:p/>
-        </p:txBody>
-      </p:sp>
-      <p:sp>
-        <p:nvSpPr>
-          <p:cNvPr id="39" name="Oval 38"/>
-          <p:cNvSpPr/>
-          <p:nvPr/>
-        </p:nvSpPr>
-        <p:spPr>
-          <a:xfrm>
-            <a:off x="1498600" y="12573000"/>
-            <a:ext cx="152400" cy="152400"/>
-          </a:xfrm>
-          <a:prstGeom prst="ellipse">
-            <a:avLst/>
-          </a:prstGeom>
-          <a:solidFill>
-            <a:srgbClr val="664092"/>
-          </a:solidFill>
-          <a:ln>
-            <a:noFill/>
-          </a:ln>
-          <a:effectLst/>
-        </p:spPr>
-        <p:txBody>
-          <a:bodyPr rtlCol="0" anchor="ctr"/>
-          <a:lstStyle/>
-          <a:p/>
-        </p:txBody>
-      </p:sp>
-      <p:sp>
-        <p:nvSpPr>
-          <p:cNvPr id="40" name="TextBox 39"/>
-          <p:cNvSpPr txBox="1"/>
-          <p:nvPr/>
-        </p:nvSpPr>
-        <p:spPr>
-          <a:xfrm>
-            <a:off x="1803400" y="12471400"/>
-            <a:ext cx="6858000" cy="355600"/>
-          </a:xfrm>
-          <a:prstGeom prst="rect">
-            <a:avLst/>
-          </a:prstGeom>
-          <a:noFill/>
-        </p:spPr>
-        <p:txBody>
-          <a:bodyPr wrap="square" lIns="0" rIns="0" tIns="0" bIns="0" anchor="ctr">
-            <a:spAutoFit/>
-          </a:bodyPr>
-          <a:lstStyle/>
-          <a:p>
-            <a:pPr algn="l"/>
-            <a:r>
-              <a:rPr sz="1550" b="0">
-                <a:solidFill>
-                  <a:srgbClr val="3D2159"/>
-                </a:solidFill>
-                <a:latin typeface="Metropolis"/>
-              </a:rPr>
-              <a:t>Parte de necesidades reales.</a:t>
-            </a:r>
-          </a:p>
-        </p:txBody>
-      </p:sp>
-      <p:sp>
-        <p:nvSpPr>
-          <p:cNvPr id="41" name="Oval 40"/>
-          <p:cNvSpPr/>
-          <p:nvPr/>
-        </p:nvSpPr>
-        <p:spPr>
-          <a:xfrm>
-            <a:off x="1498600" y="13030200"/>
-            <a:ext cx="152400" cy="152400"/>
-          </a:xfrm>
-          <a:prstGeom prst="ellipse">
-            <a:avLst/>
-          </a:prstGeom>
-          <a:solidFill>
-            <a:srgbClr val="664092"/>
-          </a:solidFill>
-          <a:ln>
-            <a:noFill/>
-          </a:ln>
-          <a:effectLst/>
-        </p:spPr>
-        <p:txBody>
-          <a:bodyPr rtlCol="0" anchor="ctr"/>
-          <a:lstStyle/>
-          <a:p/>
-        </p:txBody>
-      </p:sp>
-      <p:sp>
-        <p:nvSpPr>
-          <p:cNvPr id="42" name="TextBox 41"/>
-          <p:cNvSpPr txBox="1"/>
-          <p:nvPr/>
-        </p:nvSpPr>
-        <p:spPr>
-          <a:xfrm>
-            <a:off x="1803400" y="12928600"/>
-            <a:ext cx="6858000" cy="355600"/>
-          </a:xfrm>
-          <a:prstGeom prst="rect">
-            <a:avLst/>
-          </a:prstGeom>
-          <a:noFill/>
-        </p:spPr>
-        <p:txBody>
-          <a:bodyPr wrap="square" lIns="0" rIns="0" tIns="0" bIns="0" anchor="ctr">
-            <a:spAutoFit/>
-          </a:bodyPr>
-          <a:lstStyle/>
-          <a:p>
-            <a:pPr algn="l"/>
-            <a:r>
-              <a:rPr sz="1550" b="0">
-                <a:solidFill>
-                  <a:srgbClr val="3D2159"/>
-                </a:solidFill>
-                <a:latin typeface="Metropolis"/>
-              </a:rPr>
-              <a:t>Combina la creatividad con un proceso estructurado.</a:t>
-            </a:r>
-          </a:p>
-        </p:txBody>
-      </p:sp>
-      <p:sp>
-        <p:nvSpPr>
-          <p:cNvPr id="43" name="Oval 42"/>
-          <p:cNvSpPr/>
-          <p:nvPr/>
-        </p:nvSpPr>
-        <p:spPr>
-          <a:xfrm>
-            <a:off x="1498600" y="13487400"/>
-            <a:ext cx="152400" cy="152400"/>
-          </a:xfrm>
-          <a:prstGeom prst="ellipse">
-            <a:avLst/>
-          </a:prstGeom>
-          <a:solidFill>
-            <a:srgbClr val="664092"/>
-          </a:solidFill>
-          <a:ln>
-            <a:noFill/>
-          </a:ln>
-          <a:effectLst/>
-        </p:spPr>
-        <p:txBody>
-          <a:bodyPr rtlCol="0" anchor="ctr"/>
-          <a:lstStyle/>
-          <a:p/>
-        </p:txBody>
-      </p:sp>
-      <p:sp>
-        <p:nvSpPr>
-          <p:cNvPr id="44" name="TextBox 43"/>
-          <p:cNvSpPr txBox="1"/>
-          <p:nvPr/>
-        </p:nvSpPr>
-        <p:spPr>
-          <a:xfrm>
-            <a:off x="1803400" y="13385800"/>
-            <a:ext cx="6858000" cy="355600"/>
-          </a:xfrm>
-          <a:prstGeom prst="rect">
-            <a:avLst/>
-          </a:prstGeom>
-          <a:noFill/>
-        </p:spPr>
-        <p:txBody>
-          <a:bodyPr wrap="square" lIns="0" rIns="0" tIns="0" bIns="0" anchor="ctr">
-            <a:spAutoFit/>
-          </a:bodyPr>
-          <a:lstStyle/>
-          <a:p>
-            <a:pPr algn="l"/>
-            <a:r>
-              <a:rPr sz="1550" b="0">
-                <a:solidFill>
-                  <a:srgbClr val="3D2159"/>
-                </a:solidFill>
-                <a:latin typeface="Metropolis"/>
-              </a:rPr>
-              <a:t>Valida ideas con las personas usuarias.</a:t>
-            </a:r>
-          </a:p>
-        </p:txBody>
-      </p:sp>
-      <p:sp>
-        <p:nvSpPr>
-          <p:cNvPr id="45" name="Rounded Rectangle 44"/>
-          <p:cNvSpPr/>
-          <p:nvPr/>
-        </p:nvSpPr>
-        <p:spPr>
-          <a:xfrm>
-            <a:off x="9194800" y="9956800"/>
-            <a:ext cx="3429000" cy="4013200"/>
-          </a:xfrm>
-          <a:prstGeom prst="roundRect">
-            <a:avLst>
-              <a:gd name="adj" fmla="val 5925"/>
-            </a:avLst>
-          </a:prstGeom>
-          <a:solidFill>
-            <a:srgbClr val="F1EBF6"/>
-          </a:solidFill>
-          <a:ln>
-            <a:noFill/>
-          </a:ln>
-          <a:effectLst/>
-        </p:spPr>
-        <p:txBody>
-          <a:bodyPr rtlCol="0" anchor="ctr"/>
-          <a:lstStyle/>
-          <a:p/>
+          <a:p>
+            <a:pPr algn="ctr"/>
+          </a:p>
         </p:txBody>
       </p:sp>
       <p:pic>
@@ -4524,8 +5428,8 @@
         </p:blipFill>
         <p:spPr>
           <a:xfrm>
-            <a:off x="9525000" y="10566400"/>
-            <a:ext cx="558800" cy="558800"/>
+            <a:off x="9601200" y="12547600"/>
+            <a:ext cx="355600" cy="355600"/>
           </a:xfrm>
           <a:prstGeom prst="rect">
             <a:avLst/>
@@ -4534,14 +5438,14 @@
       </p:pic>
       <p:sp>
         <p:nvSpPr>
-          <p:cNvPr id="47" name="TextBox 46"/>
+          <p:cNvPr id="82" name="TextBox 81"/>
           <p:cNvSpPr txBox="1"/>
           <p:nvPr/>
         </p:nvSpPr>
         <p:spPr>
           <a:xfrm>
-            <a:off x="9525000" y="11277600"/>
-            <a:ext cx="2794000" cy="330200"/>
+            <a:off x="9601200" y="12979400"/>
+            <a:ext cx="2489200" cy="762000"/>
           </a:xfrm>
           <a:prstGeom prst="rect">
             <a:avLst/>
@@ -4554,106 +5458,47 @@
           </a:bodyPr>
           <a:lstStyle/>
           <a:p>
-            <a:pPr algn="l"/>
-            <a:r>
-              <a:rPr sz="1300" b="1">
+            <a:pPr algn="l">
+              <a:lnSpc>
+                <a:spcPct val="105000"/>
+              </a:lnSpc>
+            </a:pPr>
+            <a:r>
+              <a:rPr sz="1800" b="1" i="0">
                 <a:solidFill>
                   <a:srgbClr val="664092"/>
                 </a:solidFill>
-                <a:latin typeface="Metropolis"/>
-              </a:rPr>
-              <a:t>IDEA CLAVE</a:t>
-            </a:r>
-          </a:p>
-        </p:txBody>
-      </p:sp>
-      <p:sp>
-        <p:nvSpPr>
-          <p:cNvPr id="48" name="TextBox 47"/>
-          <p:cNvSpPr txBox="1"/>
-          <p:nvPr/>
-        </p:nvSpPr>
-        <p:spPr>
-          <a:xfrm>
-            <a:off x="9525000" y="11684000"/>
-            <a:ext cx="2819400" cy="1905000"/>
-          </a:xfrm>
-          <a:prstGeom prst="rect">
-            <a:avLst/>
-          </a:prstGeom>
-          <a:noFill/>
-        </p:spPr>
-        <p:txBody>
-          <a:bodyPr wrap="square" lIns="0" rIns="0" tIns="0" bIns="0" anchor="t">
-            <a:spAutoFit/>
-          </a:bodyPr>
-          <a:lstStyle/>
-          <a:p>
-            <a:pPr algn="l">
-              <a:lnSpc>
-                <a:spcPct val="108000"/>
-              </a:lnSpc>
-            </a:pPr>
-            <a:r>
-              <a:rPr sz="2200" b="1">
-                <a:solidFill>
-                  <a:srgbClr val="664092"/>
-                </a:solidFill>
-                <a:latin typeface="Metropolis"/>
+                <a:latin typeface="Arial"/>
               </a:rPr>
               <a:t>«Diseñar con y para las personas»</a:t>
             </a:r>
           </a:p>
         </p:txBody>
       </p:sp>
-      <p:sp>
-        <p:nvSpPr>
-          <p:cNvPr id="49" name="Oval 48"/>
-          <p:cNvSpPr/>
-          <p:nvPr/>
-        </p:nvSpPr>
-        <p:spPr>
-          <a:xfrm>
-            <a:off x="6578600" y="14338300"/>
-            <a:ext cx="558800" cy="558800"/>
-          </a:xfrm>
-          <a:prstGeom prst="ellipse">
-            <a:avLst/>
-          </a:prstGeom>
-          <a:solidFill>
-            <a:srgbClr val="FFFFFF"/>
-          </a:solidFill>
-          <a:ln w="25400">
-            <a:solidFill>
-              <a:srgbClr val="4E6AD5"/>
-            </a:solidFill>
-          </a:ln>
-          <a:effectLst/>
-        </p:spPr>
-        <p:txBody>
-          <a:bodyPr rtlCol="0" anchor="ctr"/>
-          <a:lstStyle/>
-          <a:p/>
-        </p:txBody>
-      </p:sp>
       <p:pic>
         <p:nvPicPr>
-          <p:cNvPr id="50" name="Picture 49" descr="plus_bl.png"/>
+          <p:cNvPr id="83" name="Picture 82" descr="">
+            <a:extLst>
+              <a:ext uri="{C183D7F6-B498-43B3-948B-1728B52AA6E4}">
+                <adec:decorative xmlns:adec="http://schemas.microsoft.com/office/drawing/2017/decorative" val="1"/>
+              </a:ext>
+            </a:extLst>
+          </p:cNvPr>
           <p:cNvPicPr>
             <a:picLocks noChangeAspect="1"/>
           </p:cNvPicPr>
           <p:nvPr/>
         </p:nvPicPr>
         <p:blipFill>
-          <a:blip r:embed="rId5"/>
+          <a:blip r:embed="rId14"/>
           <a:stretch>
             <a:fillRect/>
           </a:stretch>
         </p:blipFill>
         <p:spPr>
           <a:xfrm>
-            <a:off x="6692900" y="14452600"/>
-            <a:ext cx="330200" cy="330200"/>
+            <a:off x="10248900" y="16205200"/>
+            <a:ext cx="1143000" cy="1143000"/>
           </a:xfrm>
           <a:prstGeom prst="rect">
             <a:avLst/>
@@ -4662,24 +5507,30 @@
       </p:pic>
       <p:sp>
         <p:nvSpPr>
-          <p:cNvPr id="51" name="Rounded Rectangle 50"/>
+          <p:cNvPr id="84" name="Rounded Rectangle 83" descr="">
+            <a:extLst>
+              <a:ext uri="{C183D7F6-B498-43B3-948B-1728B52AA6E4}">
+                <adec:decorative xmlns:adec="http://schemas.microsoft.com/office/drawing/2017/decorative" val="1"/>
+              </a:ext>
+            </a:extLst>
+          </p:cNvPr>
           <p:cNvSpPr/>
           <p:nvPr/>
         </p:nvSpPr>
         <p:spPr>
           <a:xfrm>
-            <a:off x="762000" y="14935200"/>
-            <a:ext cx="12192000" cy="4673600"/>
+            <a:off x="9321800" y="17653000"/>
+            <a:ext cx="2997200" cy="1524000"/>
           </a:xfrm>
           <a:prstGeom prst="roundRect">
             <a:avLst>
-              <a:gd name="adj" fmla="val 4891"/>
+              <a:gd name="adj" fmla="val 16000"/>
             </a:avLst>
           </a:prstGeom>
           <a:solidFill>
             <a:srgbClr val="FFFFFF"/>
           </a:solidFill>
-          <a:ln w="28575">
+          <a:ln w="19050">
             <a:solidFill>
               <a:srgbClr val="2A56C6"/>
             </a:solidFill>
@@ -4689,445 +5540,9 @@
         <p:txBody>
           <a:bodyPr rtlCol="0" anchor="ctr"/>
           <a:lstStyle/>
-          <a:p/>
-        </p:txBody>
-      </p:sp>
-      <p:sp>
-        <p:nvSpPr>
-          <p:cNvPr id="52" name="Rectangle 51"/>
-          <p:cNvSpPr/>
-          <p:nvPr/>
-        </p:nvSpPr>
-        <p:spPr>
-          <a:xfrm>
-            <a:off x="762000" y="14935200"/>
-            <a:ext cx="177800" cy="4673600"/>
-          </a:xfrm>
-          <a:prstGeom prst="rect">
-            <a:avLst/>
-          </a:prstGeom>
-          <a:solidFill>
-            <a:srgbClr val="2A56C6"/>
-          </a:solidFill>
-          <a:ln>
-            <a:noFill/>
-          </a:ln>
-          <a:effectLst/>
-        </p:spPr>
-        <p:txBody>
-          <a:bodyPr rtlCol="0" anchor="ctr"/>
-          <a:lstStyle/>
-          <a:p/>
-        </p:txBody>
-      </p:sp>
-      <p:sp>
-        <p:nvSpPr>
-          <p:cNvPr id="53" name="Oval 52"/>
-          <p:cNvSpPr/>
-          <p:nvPr/>
-        </p:nvSpPr>
-        <p:spPr>
-          <a:xfrm>
-            <a:off x="1244600" y="15265400"/>
-            <a:ext cx="1066800" cy="1066800"/>
-          </a:xfrm>
-          <a:prstGeom prst="ellipse">
-            <a:avLst/>
-          </a:prstGeom>
-          <a:solidFill>
-            <a:srgbClr val="2A56C6"/>
-          </a:solidFill>
-          <a:ln>
-            <a:noFill/>
-          </a:ln>
-          <a:effectLst/>
-        </p:spPr>
-        <p:txBody>
-          <a:bodyPr rtlCol="0" anchor="ctr"/>
-          <a:lstStyle/>
-          <a:p/>
-        </p:txBody>
-      </p:sp>
-      <p:pic>
-        <p:nvPicPr>
-          <p:cNvPr id="54" name="Picture 53" descr="trending-up_w.png"/>
-          <p:cNvPicPr>
-            <a:picLocks noChangeAspect="1"/>
-          </p:cNvPicPr>
-          <p:nvPr/>
-        </p:nvPicPr>
-        <p:blipFill>
-          <a:blip r:embed="rId8"/>
-          <a:stretch>
-            <a:fillRect/>
-          </a:stretch>
-        </p:blipFill>
-        <p:spPr>
-          <a:xfrm>
-            <a:off x="1485900" y="15506700"/>
-            <a:ext cx="584200" cy="584200"/>
-          </a:xfrm>
-          <a:prstGeom prst="rect">
-            <a:avLst/>
-          </a:prstGeom>
-        </p:spPr>
-      </p:pic>
-      <p:sp>
-        <p:nvSpPr>
-          <p:cNvPr id="55" name="TextBox 54"/>
-          <p:cNvSpPr txBox="1"/>
-          <p:nvPr/>
-        </p:nvSpPr>
-        <p:spPr>
-          <a:xfrm>
-            <a:off x="2540000" y="15290800"/>
-            <a:ext cx="6350000" cy="584200"/>
-          </a:xfrm>
-          <a:prstGeom prst="rect">
-            <a:avLst/>
-          </a:prstGeom>
-          <a:noFill/>
-        </p:spPr>
-        <p:txBody>
-          <a:bodyPr wrap="square" lIns="0" rIns="0" tIns="0" bIns="0" anchor="ctr">
-            <a:spAutoFit/>
-          </a:bodyPr>
-          <a:lstStyle/>
-          <a:p>
-            <a:pPr algn="l"/>
-            <a:r>
-              <a:rPr sz="3200" b="1">
-                <a:solidFill>
-                  <a:srgbClr val="2A56C6"/>
-                </a:solidFill>
-                <a:latin typeface="Metropolis"/>
-              </a:rPr>
-              <a:t>Innovación</a:t>
-            </a:r>
-          </a:p>
-        </p:txBody>
-      </p:sp>
-      <p:sp>
-        <p:nvSpPr>
-          <p:cNvPr id="56" name="TextBox 55"/>
-          <p:cNvSpPr txBox="1"/>
-          <p:nvPr/>
-        </p:nvSpPr>
-        <p:spPr>
-          <a:xfrm>
-            <a:off x="2540000" y="15900400"/>
-            <a:ext cx="6350000" cy="381000"/>
-          </a:xfrm>
-          <a:prstGeom prst="rect">
-            <a:avLst/>
-          </a:prstGeom>
-          <a:noFill/>
-        </p:spPr>
-        <p:txBody>
-          <a:bodyPr wrap="square" lIns="0" rIns="0" tIns="0" bIns="0" anchor="ctr">
-            <a:spAutoFit/>
-          </a:bodyPr>
-          <a:lstStyle/>
-          <a:p>
-            <a:pPr algn="l"/>
-            <a:r>
-              <a:rPr sz="1800" b="1">
-                <a:solidFill>
-                  <a:srgbClr val="3D2159"/>
-                </a:solidFill>
-                <a:latin typeface="Metropolis"/>
-              </a:rPr>
-              <a:t>La puesta en práctica con impacto</a:t>
-            </a:r>
-          </a:p>
-        </p:txBody>
-      </p:sp>
-      <p:sp>
-        <p:nvSpPr>
-          <p:cNvPr id="57" name="TextBox 56"/>
-          <p:cNvSpPr txBox="1"/>
-          <p:nvPr/>
-        </p:nvSpPr>
-        <p:spPr>
-          <a:xfrm>
-            <a:off x="1244600" y="16560800"/>
-            <a:ext cx="7620000" cy="1066800"/>
-          </a:xfrm>
-          <a:prstGeom prst="rect">
-            <a:avLst/>
-          </a:prstGeom>
-          <a:noFill/>
-        </p:spPr>
-        <p:txBody>
-          <a:bodyPr wrap="square" lIns="0" rIns="0" tIns="0" bIns="0" anchor="t">
-            <a:spAutoFit/>
-          </a:bodyPr>
-          <a:lstStyle/>
-          <a:p>
-            <a:pPr algn="l">
-              <a:lnSpc>
-                <a:spcPct val="112000"/>
-              </a:lnSpc>
-            </a:pPr>
-            <a:r>
-              <a:rPr sz="1600" b="0">
-                <a:solidFill>
-                  <a:srgbClr val="455971"/>
-                </a:solidFill>
-                <a:latin typeface="Metropolis"/>
-              </a:rPr>
-              <a:t>Implementación de soluciones que generan valor real en contextos específicos, con mejoras tangibles en la vida de las personas y las organizaciones.</a:t>
-            </a:r>
-          </a:p>
-        </p:txBody>
-      </p:sp>
-      <p:sp>
-        <p:nvSpPr>
-          <p:cNvPr id="58" name="Rounded Rectangle 57"/>
-          <p:cNvSpPr/>
-          <p:nvPr/>
-        </p:nvSpPr>
-        <p:spPr>
-          <a:xfrm>
-            <a:off x="1244600" y="17602200"/>
-            <a:ext cx="7620000" cy="1651000"/>
-          </a:xfrm>
-          <a:prstGeom prst="roundRect">
-            <a:avLst>
-              <a:gd name="adj" fmla="val 9230"/>
-            </a:avLst>
-          </a:prstGeom>
-          <a:solidFill>
-            <a:srgbClr val="E8F1FB"/>
-          </a:solidFill>
-          <a:ln>
-            <a:noFill/>
-          </a:ln>
-          <a:effectLst/>
-        </p:spPr>
-        <p:txBody>
-          <a:bodyPr rtlCol="0" anchor="ctr"/>
-          <a:lstStyle/>
-          <a:p/>
-        </p:txBody>
-      </p:sp>
-      <p:sp>
-        <p:nvSpPr>
-          <p:cNvPr id="59" name="Oval 58"/>
-          <p:cNvSpPr/>
-          <p:nvPr/>
-        </p:nvSpPr>
-        <p:spPr>
-          <a:xfrm>
-            <a:off x="1498600" y="17881600"/>
-            <a:ext cx="152400" cy="152400"/>
-          </a:xfrm>
-          <a:prstGeom prst="ellipse">
-            <a:avLst/>
-          </a:prstGeom>
-          <a:solidFill>
-            <a:srgbClr val="2A56C6"/>
-          </a:solidFill>
-          <a:ln>
-            <a:noFill/>
-          </a:ln>
-          <a:effectLst/>
-        </p:spPr>
-        <p:txBody>
-          <a:bodyPr rtlCol="0" anchor="ctr"/>
-          <a:lstStyle/>
-          <a:p/>
-        </p:txBody>
-      </p:sp>
-      <p:sp>
-        <p:nvSpPr>
-          <p:cNvPr id="60" name="TextBox 59"/>
-          <p:cNvSpPr txBox="1"/>
-          <p:nvPr/>
-        </p:nvSpPr>
-        <p:spPr>
-          <a:xfrm>
-            <a:off x="1803400" y="17780000"/>
-            <a:ext cx="6858000" cy="355600"/>
-          </a:xfrm>
-          <a:prstGeom prst="rect">
-            <a:avLst/>
-          </a:prstGeom>
-          <a:noFill/>
-        </p:spPr>
-        <p:txBody>
-          <a:bodyPr wrap="square" lIns="0" rIns="0" tIns="0" bIns="0" anchor="ctr">
-            <a:spAutoFit/>
-          </a:bodyPr>
-          <a:lstStyle/>
-          <a:p>
-            <a:pPr algn="l"/>
-            <a:r>
-              <a:rPr sz="1550" b="0">
-                <a:solidFill>
-                  <a:srgbClr val="3D2159"/>
-                </a:solidFill>
-                <a:latin typeface="Metropolis"/>
-              </a:rPr>
-              <a:t>Convierte ideas en resultados.</a:t>
-            </a:r>
-          </a:p>
-        </p:txBody>
-      </p:sp>
-      <p:sp>
-        <p:nvSpPr>
-          <p:cNvPr id="61" name="Oval 60"/>
-          <p:cNvSpPr/>
-          <p:nvPr/>
-        </p:nvSpPr>
-        <p:spPr>
-          <a:xfrm>
-            <a:off x="1498600" y="18338800"/>
-            <a:ext cx="152400" cy="152400"/>
-          </a:xfrm>
-          <a:prstGeom prst="ellipse">
-            <a:avLst/>
-          </a:prstGeom>
-          <a:solidFill>
-            <a:srgbClr val="2A56C6"/>
-          </a:solidFill>
-          <a:ln>
-            <a:noFill/>
-          </a:ln>
-          <a:effectLst/>
-        </p:spPr>
-        <p:txBody>
-          <a:bodyPr rtlCol="0" anchor="ctr"/>
-          <a:lstStyle/>
-          <a:p/>
-        </p:txBody>
-      </p:sp>
-      <p:sp>
-        <p:nvSpPr>
-          <p:cNvPr id="62" name="TextBox 61"/>
-          <p:cNvSpPr txBox="1"/>
-          <p:nvPr/>
-        </p:nvSpPr>
-        <p:spPr>
-          <a:xfrm>
-            <a:off x="1803400" y="18237200"/>
-            <a:ext cx="6858000" cy="355600"/>
-          </a:xfrm>
-          <a:prstGeom prst="rect">
-            <a:avLst/>
-          </a:prstGeom>
-          <a:noFill/>
-        </p:spPr>
-        <p:txBody>
-          <a:bodyPr wrap="square" lIns="0" rIns="0" tIns="0" bIns="0" anchor="ctr">
-            <a:spAutoFit/>
-          </a:bodyPr>
-          <a:lstStyle/>
-          <a:p>
-            <a:pPr algn="l"/>
-            <a:r>
-              <a:rPr sz="1550" b="0">
-                <a:solidFill>
-                  <a:srgbClr val="3D2159"/>
-                </a:solidFill>
-                <a:latin typeface="Metropolis"/>
-              </a:rPr>
-              <a:t>Genera valor social, económico o ambiental.</a:t>
-            </a:r>
-          </a:p>
-        </p:txBody>
-      </p:sp>
-      <p:sp>
-        <p:nvSpPr>
-          <p:cNvPr id="63" name="Oval 62"/>
-          <p:cNvSpPr/>
-          <p:nvPr/>
-        </p:nvSpPr>
-        <p:spPr>
-          <a:xfrm>
-            <a:off x="1498600" y="18796000"/>
-            <a:ext cx="152400" cy="152400"/>
-          </a:xfrm>
-          <a:prstGeom prst="ellipse">
-            <a:avLst/>
-          </a:prstGeom>
-          <a:solidFill>
-            <a:srgbClr val="2A56C6"/>
-          </a:solidFill>
-          <a:ln>
-            <a:noFill/>
-          </a:ln>
-          <a:effectLst/>
-        </p:spPr>
-        <p:txBody>
-          <a:bodyPr rtlCol="0" anchor="ctr"/>
-          <a:lstStyle/>
-          <a:p/>
-        </p:txBody>
-      </p:sp>
-      <p:sp>
-        <p:nvSpPr>
-          <p:cNvPr id="64" name="TextBox 63"/>
-          <p:cNvSpPr txBox="1"/>
-          <p:nvPr/>
-        </p:nvSpPr>
-        <p:spPr>
-          <a:xfrm>
-            <a:off x="1803400" y="18694400"/>
-            <a:ext cx="6858000" cy="355600"/>
-          </a:xfrm>
-          <a:prstGeom prst="rect">
-            <a:avLst/>
-          </a:prstGeom>
-          <a:noFill/>
-        </p:spPr>
-        <p:txBody>
-          <a:bodyPr wrap="square" lIns="0" rIns="0" tIns="0" bIns="0" anchor="ctr">
-            <a:spAutoFit/>
-          </a:bodyPr>
-          <a:lstStyle/>
-          <a:p>
-            <a:pPr algn="l"/>
-            <a:r>
-              <a:rPr sz="1550" b="0">
-                <a:solidFill>
-                  <a:srgbClr val="3D2159"/>
-                </a:solidFill>
-                <a:latin typeface="Metropolis"/>
-              </a:rPr>
-              <a:t>Implica apropiación, sostenibilidad y escala.</a:t>
-            </a:r>
-          </a:p>
-        </p:txBody>
-      </p:sp>
-      <p:sp>
-        <p:nvSpPr>
-          <p:cNvPr id="65" name="Rounded Rectangle 64"/>
-          <p:cNvSpPr/>
-          <p:nvPr/>
-        </p:nvSpPr>
-        <p:spPr>
-          <a:xfrm>
-            <a:off x="9194800" y="15265400"/>
-            <a:ext cx="3429000" cy="4013200"/>
-          </a:xfrm>
-          <a:prstGeom prst="roundRect">
-            <a:avLst>
-              <a:gd name="adj" fmla="val 5925"/>
-            </a:avLst>
-          </a:prstGeom>
-          <a:solidFill>
-            <a:srgbClr val="E8F1FB"/>
-          </a:solidFill>
-          <a:ln>
-            <a:noFill/>
-          </a:ln>
-          <a:effectLst/>
-        </p:spPr>
-        <p:txBody>
-          <a:bodyPr rtlCol="0" anchor="ctr"/>
-          <a:lstStyle/>
-          <a:p/>
+          <a:p>
+            <a:pPr algn="ctr"/>
+          </a:p>
         </p:txBody>
       </p:sp>
       <p:pic>
@@ -5146,8 +5561,8 @@
         </p:blipFill>
         <p:spPr>
           <a:xfrm>
-            <a:off x="9525000" y="15875000"/>
-            <a:ext cx="558800" cy="558800"/>
+            <a:off x="9601200" y="17881600"/>
+            <a:ext cx="355600" cy="355600"/>
           </a:xfrm>
           <a:prstGeom prst="rect">
             <a:avLst/>
@@ -5156,14 +5571,14 @@
       </p:pic>
       <p:sp>
         <p:nvSpPr>
-          <p:cNvPr id="67" name="TextBox 66"/>
+          <p:cNvPr id="85" name="TextBox 84"/>
           <p:cNvSpPr txBox="1"/>
           <p:nvPr/>
         </p:nvSpPr>
         <p:spPr>
           <a:xfrm>
-            <a:off x="9525000" y="16586200"/>
-            <a:ext cx="2794000" cy="330200"/>
+            <a:off x="9601200" y="18313400"/>
+            <a:ext cx="2489200" cy="762000"/>
           </a:xfrm>
           <a:prstGeom prst="rect">
             <a:avLst/>
@@ -5176,52 +5591,17 @@
           </a:bodyPr>
           <a:lstStyle/>
           <a:p>
-            <a:pPr algn="l"/>
-            <a:r>
-              <a:rPr sz="1300" b="1">
+            <a:pPr algn="l">
+              <a:lnSpc>
+                <a:spcPct val="105000"/>
+              </a:lnSpc>
+            </a:pPr>
+            <a:r>
+              <a:rPr sz="1800" b="1" i="0">
                 <a:solidFill>
                   <a:srgbClr val="2A56C6"/>
                 </a:solidFill>
-                <a:latin typeface="Metropolis"/>
-              </a:rPr>
-              <a:t>IDEA CLAVE</a:t>
-            </a:r>
-          </a:p>
-        </p:txBody>
-      </p:sp>
-      <p:sp>
-        <p:nvSpPr>
-          <p:cNvPr id="68" name="TextBox 67"/>
-          <p:cNvSpPr txBox="1"/>
-          <p:nvPr/>
-        </p:nvSpPr>
-        <p:spPr>
-          <a:xfrm>
-            <a:off x="9525000" y="16992600"/>
-            <a:ext cx="2819400" cy="1905000"/>
-          </a:xfrm>
-          <a:prstGeom prst="rect">
-            <a:avLst/>
-          </a:prstGeom>
-          <a:noFill/>
-        </p:spPr>
-        <p:txBody>
-          <a:bodyPr wrap="square" lIns="0" rIns="0" tIns="0" bIns="0" anchor="t">
-            <a:spAutoFit/>
-          </a:bodyPr>
-          <a:lstStyle/>
-          <a:p>
-            <a:pPr algn="l">
-              <a:lnSpc>
-                <a:spcPct val="108000"/>
-              </a:lnSpc>
-            </a:pPr>
-            <a:r>
-              <a:rPr sz="2200" b="1">
-                <a:solidFill>
-                  <a:srgbClr val="2A56C6"/>
-                </a:solidFill>
-                <a:latin typeface="Metropolis"/>
+                <a:latin typeface="Arial"/>
               </a:rPr>
               <a:t>“Hacer que suceda en el mundo real”</a:t>
             </a:r>
@@ -5230,23 +5610,37 @@
       </p:sp>
       <p:sp>
         <p:nvSpPr>
-          <p:cNvPr id="69" name="Rounded Rectangle 68"/>
+          <p:cNvPr id="86" name="Rounded Rectangle 85" descr="">
+            <a:extLst>
+              <a:ext uri="{C183D7F6-B498-43B3-948B-1728B52AA6E4}">
+                <adec:decorative xmlns:adec="http://schemas.microsoft.com/office/drawing/2017/decorative" val="1"/>
+              </a:ext>
+            </a:extLst>
+          </p:cNvPr>
           <p:cNvSpPr/>
           <p:nvPr/>
         </p:nvSpPr>
         <p:spPr>
           <a:xfrm>
-            <a:off x="762000" y="19989800"/>
-            <a:ext cx="12192000" cy="1701800"/>
+            <a:off x="762000" y="4318000"/>
+            <a:ext cx="12192000" cy="63500"/>
           </a:xfrm>
           <a:prstGeom prst="roundRect">
             <a:avLst>
-              <a:gd name="adj" fmla="val 13432"/>
+              <a:gd name="adj" fmla="val 50000"/>
             </a:avLst>
           </a:prstGeom>
-          <a:solidFill>
-            <a:srgbClr val="3D2159"/>
-          </a:solidFill>
+          <a:gradFill rotWithShape="1">
+            <a:gsLst>
+              <a:gs pos="0">
+                <a:srgbClr val="5B2C8F"/>
+              </a:gs>
+              <a:gs pos="100000">
+                <a:srgbClr val="5FD3E0"/>
+              </a:gs>
+            </a:gsLst>
+            <a:lin ang="0" scaled="0"/>
+          </a:gradFill>
           <a:ln>
             <a:noFill/>
           </a:ln>
@@ -5255,246 +5649,11 @@
         <p:txBody>
           <a:bodyPr rtlCol="0" anchor="ctr"/>
           <a:lstStyle/>
-          <a:p/>
-        </p:txBody>
-      </p:sp>
-      <p:sp>
-        <p:nvSpPr>
-          <p:cNvPr id="70" name="Oval 69"/>
-          <p:cNvSpPr/>
-          <p:nvPr/>
-        </p:nvSpPr>
-        <p:spPr>
-          <a:xfrm>
-            <a:off x="1168400" y="20332700"/>
-            <a:ext cx="1016000" cy="1016000"/>
-          </a:xfrm>
-          <a:prstGeom prst="ellipse">
-            <a:avLst/>
-          </a:prstGeom>
-          <a:solidFill>
-            <a:srgbClr val="FFD900"/>
-          </a:solidFill>
-          <a:ln>
-            <a:noFill/>
-          </a:ln>
-          <a:effectLst/>
-        </p:spPr>
-        <p:txBody>
-          <a:bodyPr rtlCol="0" anchor="ctr"/>
-          <a:lstStyle/>
-          <a:p/>
-        </p:txBody>
-      </p:sp>
-      <p:pic>
-        <p:nvPicPr>
-          <p:cNvPr id="71" name="Picture 70" descr="target_dk.png"/>
-          <p:cNvPicPr>
-            <a:picLocks noChangeAspect="1"/>
-          </p:cNvPicPr>
-          <p:nvPr/>
-        </p:nvPicPr>
-        <p:blipFill>
-          <a:blip r:embed="rId10"/>
-          <a:stretch>
-            <a:fillRect/>
-          </a:stretch>
-        </p:blipFill>
-        <p:spPr>
-          <a:xfrm>
-            <a:off x="1397000" y="20561300"/>
-            <a:ext cx="558800" cy="558800"/>
-          </a:xfrm>
-          <a:prstGeom prst="rect">
-            <a:avLst/>
-          </a:prstGeom>
-        </p:spPr>
-      </p:pic>
-      <p:sp>
-        <p:nvSpPr>
-          <p:cNvPr id="72" name="Rounded Rectangle 71"/>
-          <p:cNvSpPr/>
-          <p:nvPr/>
-        </p:nvSpPr>
-        <p:spPr>
-          <a:xfrm>
-            <a:off x="2540000" y="20243800"/>
-            <a:ext cx="3175000" cy="406400"/>
-          </a:xfrm>
-          <a:prstGeom prst="roundRect">
-            <a:avLst>
-              <a:gd name="adj" fmla="val 50000"/>
-            </a:avLst>
-          </a:prstGeom>
-          <a:solidFill>
-            <a:srgbClr val="FFD900"/>
-          </a:solidFill>
-          <a:ln>
-            <a:noFill/>
-          </a:ln>
-          <a:effectLst/>
-        </p:spPr>
-        <p:txBody>
-          <a:bodyPr rtlCol="0" anchor="ctr"/>
-          <a:lstStyle/>
-          <a:p/>
-        </p:txBody>
-      </p:sp>
-      <p:sp>
-        <p:nvSpPr>
-          <p:cNvPr id="73" name="TextBox 72"/>
-          <p:cNvSpPr txBox="1"/>
-          <p:nvPr/>
-        </p:nvSpPr>
-        <p:spPr>
-          <a:xfrm>
-            <a:off x="2540000" y="20243800"/>
-            <a:ext cx="3175000" cy="406400"/>
-          </a:xfrm>
-          <a:prstGeom prst="rect">
-            <a:avLst/>
-          </a:prstGeom>
-          <a:noFill/>
-        </p:spPr>
-        <p:txBody>
-          <a:bodyPr wrap="square" lIns="0" rIns="0" tIns="0" bIns="0" anchor="ctr">
-            <a:spAutoFit/>
-          </a:bodyPr>
-          <a:lstStyle/>
           <a:p>
             <a:pPr algn="ctr"/>
-            <a:r>
-              <a:rPr sz="1400" b="1">
-                <a:solidFill>
-                  <a:srgbClr val="3D2159"/>
-                </a:solidFill>
-                <a:latin typeface="Metropolis"/>
-              </a:rPr>
-              <a:t>UN MISMO PROPÓSITO</a:t>
-            </a:r>
-          </a:p>
-        </p:txBody>
-      </p:sp>
-      <p:sp>
-        <p:nvSpPr>
-          <p:cNvPr id="74" name="TextBox 73"/>
-          <p:cNvSpPr txBox="1"/>
-          <p:nvPr/>
-        </p:nvSpPr>
-        <p:spPr>
-          <a:xfrm>
-            <a:off x="2540000" y="20726400"/>
-            <a:ext cx="10033000" cy="812800"/>
-          </a:xfrm>
-          <a:prstGeom prst="rect">
-            <a:avLst/>
-          </a:prstGeom>
-          <a:noFill/>
-        </p:spPr>
-        <p:txBody>
-          <a:bodyPr wrap="square" lIns="0" rIns="0" tIns="0" bIns="0" anchor="ctr">
-            <a:spAutoFit/>
-          </a:bodyPr>
-          <a:lstStyle/>
-          <a:p>
-            <a:pPr algn="l">
-              <a:lnSpc>
-                <a:spcPct val="108000"/>
-              </a:lnSpc>
-            </a:pPr>
-            <a:r>
-              <a:rPr sz="1900" b="1">
-                <a:solidFill>
-                  <a:srgbClr val="FFFFFF"/>
-                </a:solidFill>
-                <a:latin typeface="Metropolis"/>
-              </a:rPr>
-              <a:t>Generar soluciones con sentido, </a:t>
-            </a:r>
-            <a:r>
-              <a:rPr sz="1900" b="0">
-                <a:solidFill>
-                  <a:srgbClr val="FFFFFF"/>
-                </a:solidFill>
-                <a:latin typeface="Metropolis"/>
-              </a:rPr>
-              <a:t>que respondan a necesidades reales y mejoren la vida de las personas.</a:t>
-            </a:r>
-          </a:p>
-        </p:txBody>
-      </p:sp>
-      <p:sp>
-        <p:nvSpPr>
-          <p:cNvPr id="75" name="TextBox 74"/>
-          <p:cNvSpPr txBox="1"/>
-          <p:nvPr/>
-        </p:nvSpPr>
-        <p:spPr>
-          <a:xfrm>
-            <a:off x="762000" y="21894800"/>
-            <a:ext cx="12192000" cy="558800"/>
-          </a:xfrm>
-          <a:prstGeom prst="rect">
-            <a:avLst/>
-          </a:prstGeom>
-          <a:noFill/>
-        </p:spPr>
-        <p:txBody>
-          <a:bodyPr wrap="square" lIns="0" rIns="0" tIns="0" bIns="0" anchor="t">
-            <a:spAutoFit/>
-          </a:bodyPr>
-          <a:lstStyle/>
-          <a:p>
-            <a:pPr algn="l">
-              <a:lnSpc>
-                <a:spcPct val="108000"/>
-              </a:lnSpc>
-            </a:pPr>
-            <a:r>
-              <a:rPr sz="1300" b="1">
-                <a:solidFill>
-                  <a:srgbClr val="044992"/>
-                </a:solidFill>
-                <a:latin typeface="Metropolis"/>
-              </a:rPr>
-              <a:t>Nota. </a:t>
-            </a:r>
-            <a:r>
-              <a:rPr sz="1300" b="0">
-                <a:solidFill>
-                  <a:srgbClr val="044992"/>
-                </a:solidFill>
-                <a:latin typeface="Metropolis"/>
-              </a:rPr>
-              <a:t>Elaboración propia con base en Brown (2008), IDEO.org (2015) y Hasso Plattner Institute of Design at Stanford (s. f.).</a:t>
-            </a:r>
-          </a:p>
-        </p:txBody>
-      </p:sp>
-      <p:pic>
-        <p:nvPicPr>
-          <p:cNvPr id="76" name="Picture 75" descr="logos.png"/>
-          <p:cNvPicPr>
-            <a:picLocks noChangeAspect="1"/>
-          </p:cNvPicPr>
-          <p:nvPr/>
-        </p:nvPicPr>
-        <p:blipFill>
-          <a:blip r:embed="rId11"/>
-          <a:stretch>
-            <a:fillRect/>
-          </a:stretch>
-        </p:blipFill>
-        <p:spPr>
-          <a:xfrm>
-            <a:off x="8128000" y="23241000"/>
-            <a:ext cx="4826000" cy="814166"/>
-          </a:xfrm>
-          <a:prstGeom prst="rect">
-            <a:avLst/>
-          </a:prstGeom>
-        </p:spPr>
-      </p:pic>
+          </a:p>
+        </p:txBody>
+      </p:sp>
     </p:spTree>
   </p:cSld>
   <p:clrMapOvr>

</xml_diff>

<commit_message>
C4 M2 infografía: íconos rellenos, conectores sólidos y más separación
Co-Authored-By: Claude Opus 5.5 <noreply@anthropic.com>
Claude-Session: https://claude.ai/code/session_01ECfkxKzanoc9tBzEYwq5z6
</commit_message>
<xml_diff>
--- a/entregas/curso4_modulo2/C4_M2_03_Infografia_Creatividad_pensamiento_de_diseno_e_innovacion_EDITABLE.pptx
+++ b/entregas/curso4_modulo2/C4_M2_03_Infografia_Creatividad_pensamiento_de_diseno_e_innovacion_EDITABLE.pptx
@@ -3424,8 +3424,8 @@
         </p:nvSpPr>
         <p:spPr>
           <a:xfrm>
-            <a:off x="762000" y="4851400"/>
-            <a:ext cx="12192000" cy="4724400"/>
+            <a:off x="762000" y="4800600"/>
+            <a:ext cx="12192000" cy="4622800"/>
           </a:xfrm>
           <a:prstGeom prst="roundRect">
             <a:avLst>
@@ -3456,8 +3456,8 @@
         </p:nvSpPr>
         <p:spPr>
           <a:xfrm>
-            <a:off x="762000" y="4851400"/>
-            <a:ext cx="177800" cy="4724400"/>
+            <a:off x="965200" y="5156200"/>
+            <a:ext cx="88900" cy="3911600"/>
           </a:xfrm>
           <a:prstGeom prst="rect">
             <a:avLst/>
@@ -3484,7 +3484,7 @@
         </p:nvSpPr>
         <p:spPr>
           <a:xfrm>
-            <a:off x="1270000" y="5232400"/>
+            <a:off x="1270000" y="5181600"/>
             <a:ext cx="1066800" cy="1066800"/>
           </a:xfrm>
           <a:prstGeom prst="ellipse">
@@ -3506,22 +3506,22 @@
       </p:sp>
       <p:pic>
         <p:nvPicPr>
-          <p:cNvPr id="14" name="Picture 13" descr="lightbulb_dk.png"/>
+          <p:cNvPr id="87" name="Picture 86" descr="ph_lightbulb-fill_3D2159.png"/>
           <p:cNvPicPr>
             <a:picLocks noChangeAspect="1"/>
           </p:cNvPicPr>
           <p:nvPr/>
         </p:nvPicPr>
         <p:blipFill>
-          <a:blip r:embed="rId3"/>
+          <a:blip r:embed="rId15"/>
           <a:stretch>
             <a:fillRect/>
           </a:stretch>
         </p:blipFill>
         <p:spPr>
           <a:xfrm>
-            <a:off x="1511300" y="5473700"/>
-            <a:ext cx="584200" cy="584200"/>
+            <a:off x="1485900" y="5397500"/>
+            <a:ext cx="635000" cy="635000"/>
           </a:xfrm>
           <a:prstGeom prst="rect">
             <a:avLst/>
@@ -3536,7 +3536,7 @@
         </p:nvSpPr>
         <p:spPr>
           <a:xfrm>
-            <a:off x="2590800" y="5257800"/>
+            <a:off x="2590800" y="5207000"/>
             <a:ext cx="6096000" cy="584200"/>
           </a:xfrm>
           <a:prstGeom prst="rect">
@@ -3571,7 +3571,7 @@
         </p:nvSpPr>
         <p:spPr>
           <a:xfrm>
-            <a:off x="2590800" y="5867400"/>
+            <a:off x="2590800" y="5816600"/>
             <a:ext cx="6096000" cy="381000"/>
           </a:xfrm>
           <a:prstGeom prst="rect">
@@ -3606,7 +3606,7 @@
         </p:nvSpPr>
         <p:spPr>
           <a:xfrm>
-            <a:off x="1270000" y="6527800"/>
+            <a:off x="1270000" y="6477000"/>
             <a:ext cx="7416800" cy="1143000"/>
           </a:xfrm>
           <a:prstGeom prst="rect">
@@ -3645,7 +3645,7 @@
         </p:nvSpPr>
         <p:spPr>
           <a:xfrm>
-            <a:off x="1270000" y="7772400"/>
+            <a:off x="1270000" y="7721600"/>
             <a:ext cx="7416800" cy="1498600"/>
           </a:xfrm>
           <a:prstGeom prst="roundRect">
@@ -3675,7 +3675,7 @@
         </p:nvSpPr>
         <p:spPr>
           <a:xfrm>
-            <a:off x="1574800" y="8128000"/>
+            <a:off x="1574800" y="8077200"/>
             <a:ext cx="139700" cy="139700"/>
           </a:xfrm>
           <a:prstGeom prst="ellipse">
@@ -3703,7 +3703,7 @@
         </p:nvSpPr>
         <p:spPr>
           <a:xfrm>
-            <a:off x="1879600" y="8013700"/>
+            <a:off x="1879600" y="7962900"/>
             <a:ext cx="6604000" cy="381000"/>
           </a:xfrm>
           <a:prstGeom prst="rect">
@@ -3738,7 +3738,7 @@
         </p:nvSpPr>
         <p:spPr>
           <a:xfrm>
-            <a:off x="1574800" y="8534400"/>
+            <a:off x="1574800" y="8483600"/>
             <a:ext cx="139700" cy="139700"/>
           </a:xfrm>
           <a:prstGeom prst="ellipse">
@@ -3766,7 +3766,7 @@
         </p:nvSpPr>
         <p:spPr>
           <a:xfrm>
-            <a:off x="1879600" y="8420100"/>
+            <a:off x="1879600" y="8369300"/>
             <a:ext cx="6604000" cy="381000"/>
           </a:xfrm>
           <a:prstGeom prst="rect">
@@ -3801,7 +3801,7 @@
         </p:nvSpPr>
         <p:spPr>
           <a:xfrm>
-            <a:off x="1574800" y="8940800"/>
+            <a:off x="1574800" y="8890000"/>
             <a:ext cx="139700" cy="139700"/>
           </a:xfrm>
           <a:prstGeom prst="ellipse">
@@ -3829,7 +3829,7 @@
         </p:nvSpPr>
         <p:spPr>
           <a:xfrm>
-            <a:off x="1879600" y="8826500"/>
+            <a:off x="1879600" y="8775700"/>
             <a:ext cx="6604000" cy="381000"/>
           </a:xfrm>
           <a:prstGeom prst="rect">
@@ -3864,8 +3864,8 @@
         </p:nvSpPr>
         <p:spPr>
           <a:xfrm>
-            <a:off x="9093200" y="5232400"/>
-            <a:ext cx="3454400" cy="3962400"/>
+            <a:off x="9093200" y="5181600"/>
+            <a:ext cx="3454400" cy="3860800"/>
           </a:xfrm>
           <a:prstGeom prst="roundRect">
             <a:avLst>
@@ -3894,19 +3894,17 @@
         </p:nvSpPr>
         <p:spPr>
           <a:xfrm>
-            <a:off x="6578600" y="9601200"/>
-            <a:ext cx="558800" cy="558800"/>
+            <a:off x="6604000" y="9626600"/>
+            <a:ext cx="508000" cy="508000"/>
           </a:xfrm>
           <a:prstGeom prst="ellipse">
             <a:avLst/>
           </a:prstGeom>
           <a:solidFill>
-            <a:srgbClr val="FFFFFF"/>
+            <a:srgbClr val="1FA9B8"/>
           </a:solidFill>
           <a:ln w="31750">
-            <a:solidFill>
-              <a:srgbClr val="2BB3C0"/>
-            </a:solidFill>
+            <a:noFill/>
           </a:ln>
           <a:effectLst/>
         </p:spPr>
@@ -3918,22 +3916,22 @@
       </p:sp>
       <p:pic>
         <p:nvPicPr>
-          <p:cNvPr id="30" name="Picture 29" descr="plus_bl.png"/>
+          <p:cNvPr id="96" name="Picture 95" descr="ph_plus-bold_FFFFFF.png"/>
           <p:cNvPicPr>
             <a:picLocks noChangeAspect="1"/>
           </p:cNvPicPr>
           <p:nvPr/>
         </p:nvPicPr>
         <p:blipFill>
-          <a:blip r:embed="rId5"/>
+          <a:blip r:embed="rId24"/>
           <a:stretch>
             <a:fillRect/>
           </a:stretch>
         </p:blipFill>
         <p:spPr>
           <a:xfrm>
-            <a:off x="6692900" y="9715500"/>
-            <a:ext cx="330200" cy="330200"/>
+            <a:off x="6731000" y="9753600"/>
+            <a:ext cx="254000" cy="254000"/>
           </a:xfrm>
           <a:prstGeom prst="rect">
             <a:avLst/>
@@ -3948,8 +3946,8 @@
         </p:nvSpPr>
         <p:spPr>
           <a:xfrm>
-            <a:off x="762000" y="10185400"/>
-            <a:ext cx="12192000" cy="4724400"/>
+            <a:off x="762000" y="10337800"/>
+            <a:ext cx="12192000" cy="4622800"/>
           </a:xfrm>
           <a:prstGeom prst="roundRect">
             <a:avLst>
@@ -3980,8 +3978,8 @@
         </p:nvSpPr>
         <p:spPr>
           <a:xfrm>
-            <a:off x="762000" y="10185400"/>
-            <a:ext cx="177800" cy="4724400"/>
+            <a:off x="965200" y="10693400"/>
+            <a:ext cx="88900" cy="3911600"/>
           </a:xfrm>
           <a:prstGeom prst="rect">
             <a:avLst/>
@@ -4008,7 +4006,7 @@
         </p:nvSpPr>
         <p:spPr>
           <a:xfrm>
-            <a:off x="1270000" y="10566400"/>
+            <a:off x="1270000" y="10718800"/>
             <a:ext cx="1066800" cy="1066800"/>
           </a:xfrm>
           <a:prstGeom prst="ellipse">
@@ -4030,22 +4028,22 @@
       </p:sp>
       <p:pic>
         <p:nvPicPr>
-          <p:cNvPr id="34" name="Picture 33" descr="users-round_w.png"/>
+          <p:cNvPr id="88" name="Picture 87" descr="ph_users-three-fill_FFFFFF.png"/>
           <p:cNvPicPr>
             <a:picLocks noChangeAspect="1"/>
           </p:cNvPicPr>
           <p:nvPr/>
         </p:nvPicPr>
         <p:blipFill>
-          <a:blip r:embed="rId6"/>
+          <a:blip r:embed="rId16"/>
           <a:stretch>
             <a:fillRect/>
           </a:stretch>
         </p:blipFill>
         <p:spPr>
           <a:xfrm>
-            <a:off x="1511300" y="10807700"/>
-            <a:ext cx="584200" cy="584200"/>
+            <a:off x="1485900" y="10934700"/>
+            <a:ext cx="635000" cy="635000"/>
           </a:xfrm>
           <a:prstGeom prst="rect">
             <a:avLst/>
@@ -4060,7 +4058,7 @@
         </p:nvSpPr>
         <p:spPr>
           <a:xfrm>
-            <a:off x="2590800" y="10591800"/>
+            <a:off x="2590800" y="10744200"/>
             <a:ext cx="6096000" cy="584200"/>
           </a:xfrm>
           <a:prstGeom prst="rect">
@@ -4095,7 +4093,7 @@
         </p:nvSpPr>
         <p:spPr>
           <a:xfrm>
-            <a:off x="2590800" y="11201400"/>
+            <a:off x="2590800" y="11353800"/>
             <a:ext cx="6096000" cy="381000"/>
           </a:xfrm>
           <a:prstGeom prst="rect">
@@ -4130,7 +4128,7 @@
         </p:nvSpPr>
         <p:spPr>
           <a:xfrm>
-            <a:off x="1270000" y="11861800"/>
+            <a:off x="1270000" y="12014200"/>
             <a:ext cx="7416800" cy="1143000"/>
           </a:xfrm>
           <a:prstGeom prst="rect">
@@ -4169,7 +4167,7 @@
         </p:nvSpPr>
         <p:spPr>
           <a:xfrm>
-            <a:off x="1270000" y="13106400"/>
+            <a:off x="1270000" y="13258800"/>
             <a:ext cx="7416800" cy="1498600"/>
           </a:xfrm>
           <a:prstGeom prst="roundRect">
@@ -4199,7 +4197,7 @@
         </p:nvSpPr>
         <p:spPr>
           <a:xfrm>
-            <a:off x="1574800" y="13462000"/>
+            <a:off x="1574800" y="13614400"/>
             <a:ext cx="139700" cy="139700"/>
           </a:xfrm>
           <a:prstGeom prst="ellipse">
@@ -4227,7 +4225,7 @@
         </p:nvSpPr>
         <p:spPr>
           <a:xfrm>
-            <a:off x="1879600" y="13347700"/>
+            <a:off x="1879600" y="13500100"/>
             <a:ext cx="6604000" cy="381000"/>
           </a:xfrm>
           <a:prstGeom prst="rect">
@@ -4262,7 +4260,7 @@
         </p:nvSpPr>
         <p:spPr>
           <a:xfrm>
-            <a:off x="1574800" y="13868400"/>
+            <a:off x="1574800" y="14020800"/>
             <a:ext cx="139700" cy="139700"/>
           </a:xfrm>
           <a:prstGeom prst="ellipse">
@@ -4290,7 +4288,7 @@
         </p:nvSpPr>
         <p:spPr>
           <a:xfrm>
-            <a:off x="1879600" y="13754100"/>
+            <a:off x="1879600" y="13906500"/>
             <a:ext cx="6604000" cy="381000"/>
           </a:xfrm>
           <a:prstGeom prst="rect">
@@ -4325,7 +4323,7 @@
         </p:nvSpPr>
         <p:spPr>
           <a:xfrm>
-            <a:off x="1574800" y="14274800"/>
+            <a:off x="1574800" y="14427200"/>
             <a:ext cx="139700" cy="139700"/>
           </a:xfrm>
           <a:prstGeom prst="ellipse">
@@ -4353,7 +4351,7 @@
         </p:nvSpPr>
         <p:spPr>
           <a:xfrm>
-            <a:off x="1879600" y="14160500"/>
+            <a:off x="1879600" y="14312900"/>
             <a:ext cx="6604000" cy="381000"/>
           </a:xfrm>
           <a:prstGeom prst="rect">
@@ -4388,8 +4386,8 @@
         </p:nvSpPr>
         <p:spPr>
           <a:xfrm>
-            <a:off x="9093200" y="10566400"/>
-            <a:ext cx="3454400" cy="3962400"/>
+            <a:off x="9093200" y="10718800"/>
+            <a:ext cx="3454400" cy="3860800"/>
           </a:xfrm>
           <a:prstGeom prst="roundRect">
             <a:avLst>
@@ -4418,19 +4416,17 @@
         </p:nvSpPr>
         <p:spPr>
           <a:xfrm>
-            <a:off x="6578600" y="14935200"/>
-            <a:ext cx="558800" cy="558800"/>
+            <a:off x="6604000" y="15163800"/>
+            <a:ext cx="508000" cy="508000"/>
           </a:xfrm>
           <a:prstGeom prst="ellipse">
             <a:avLst/>
           </a:prstGeom>
           <a:solidFill>
-            <a:srgbClr val="FFFFFF"/>
+            <a:srgbClr val="1FA9B8"/>
           </a:solidFill>
           <a:ln w="31750">
-            <a:solidFill>
-              <a:srgbClr val="2BB3C0"/>
-            </a:solidFill>
+            <a:noFill/>
           </a:ln>
           <a:effectLst/>
         </p:spPr>
@@ -4442,22 +4438,22 @@
       </p:sp>
       <p:pic>
         <p:nvPicPr>
-          <p:cNvPr id="50" name="Picture 49" descr="plus_bl.png"/>
+          <p:cNvPr id="97" name="Picture 96" descr="ph_plus-bold_FFFFFF.png"/>
           <p:cNvPicPr>
             <a:picLocks noChangeAspect="1"/>
           </p:cNvPicPr>
           <p:nvPr/>
         </p:nvPicPr>
         <p:blipFill>
-          <a:blip r:embed="rId5"/>
+          <a:blip r:embed="rId24"/>
           <a:stretch>
             <a:fillRect/>
           </a:stretch>
         </p:blipFill>
         <p:spPr>
           <a:xfrm>
-            <a:off x="6692900" y="15049500"/>
-            <a:ext cx="330200" cy="330200"/>
+            <a:off x="6731000" y="15290800"/>
+            <a:ext cx="254000" cy="254000"/>
           </a:xfrm>
           <a:prstGeom prst="rect">
             <a:avLst/>
@@ -4472,8 +4468,8 @@
         </p:nvSpPr>
         <p:spPr>
           <a:xfrm>
-            <a:off x="762000" y="15519400"/>
-            <a:ext cx="12192000" cy="4724400"/>
+            <a:off x="762000" y="15875000"/>
+            <a:ext cx="12192000" cy="4622800"/>
           </a:xfrm>
           <a:prstGeom prst="roundRect">
             <a:avLst>
@@ -4504,8 +4500,8 @@
         </p:nvSpPr>
         <p:spPr>
           <a:xfrm>
-            <a:off x="762000" y="15519400"/>
-            <a:ext cx="177800" cy="4724400"/>
+            <a:off x="965200" y="16230600"/>
+            <a:ext cx="88900" cy="3911600"/>
           </a:xfrm>
           <a:prstGeom prst="rect">
             <a:avLst/>
@@ -4532,7 +4528,7 @@
         </p:nvSpPr>
         <p:spPr>
           <a:xfrm>
-            <a:off x="1270000" y="15900400"/>
+            <a:off x="1270000" y="16256000"/>
             <a:ext cx="1066800" cy="1066800"/>
           </a:xfrm>
           <a:prstGeom prst="ellipse">
@@ -4554,22 +4550,22 @@
       </p:sp>
       <p:pic>
         <p:nvPicPr>
-          <p:cNvPr id="54" name="Picture 53" descr="trending-up_w.png"/>
+          <p:cNvPr id="89" name="Picture 88" descr="ph_chart-bar-fill_FFFFFF.png"/>
           <p:cNvPicPr>
             <a:picLocks noChangeAspect="1"/>
           </p:cNvPicPr>
           <p:nvPr/>
         </p:nvPicPr>
         <p:blipFill>
-          <a:blip r:embed="rId8"/>
+          <a:blip r:embed="rId17"/>
           <a:stretch>
             <a:fillRect/>
           </a:stretch>
         </p:blipFill>
         <p:spPr>
           <a:xfrm>
-            <a:off x="1511300" y="16141700"/>
-            <a:ext cx="584200" cy="584200"/>
+            <a:off x="1485900" y="16471900"/>
+            <a:ext cx="635000" cy="635000"/>
           </a:xfrm>
           <a:prstGeom prst="rect">
             <a:avLst/>
@@ -4584,7 +4580,7 @@
         </p:nvSpPr>
         <p:spPr>
           <a:xfrm>
-            <a:off x="2590800" y="15925800"/>
+            <a:off x="2590800" y="16281400"/>
             <a:ext cx="6096000" cy="584200"/>
           </a:xfrm>
           <a:prstGeom prst="rect">
@@ -4619,7 +4615,7 @@
         </p:nvSpPr>
         <p:spPr>
           <a:xfrm>
-            <a:off x="2590800" y="16535400"/>
+            <a:off x="2590800" y="16891000"/>
             <a:ext cx="6096000" cy="381000"/>
           </a:xfrm>
           <a:prstGeom prst="rect">
@@ -4654,7 +4650,7 @@
         </p:nvSpPr>
         <p:spPr>
           <a:xfrm>
-            <a:off x="1270000" y="17195800"/>
+            <a:off x="1270000" y="17551400"/>
             <a:ext cx="7416800" cy="1143000"/>
           </a:xfrm>
           <a:prstGeom prst="rect">
@@ -4693,7 +4689,7 @@
         </p:nvSpPr>
         <p:spPr>
           <a:xfrm>
-            <a:off x="1270000" y="18440400"/>
+            <a:off x="1270000" y="18796000"/>
             <a:ext cx="7416800" cy="1498600"/>
           </a:xfrm>
           <a:prstGeom prst="roundRect">
@@ -4723,7 +4719,7 @@
         </p:nvSpPr>
         <p:spPr>
           <a:xfrm>
-            <a:off x="1574800" y="18796000"/>
+            <a:off x="1574800" y="19151600"/>
             <a:ext cx="139700" cy="139700"/>
           </a:xfrm>
           <a:prstGeom prst="ellipse">
@@ -4751,7 +4747,7 @@
         </p:nvSpPr>
         <p:spPr>
           <a:xfrm>
-            <a:off x="1879600" y="18681700"/>
+            <a:off x="1879600" y="19037300"/>
             <a:ext cx="6604000" cy="381000"/>
           </a:xfrm>
           <a:prstGeom prst="rect">
@@ -4786,7 +4782,7 @@
         </p:nvSpPr>
         <p:spPr>
           <a:xfrm>
-            <a:off x="1574800" y="19202400"/>
+            <a:off x="1574800" y="19558000"/>
             <a:ext cx="139700" cy="139700"/>
           </a:xfrm>
           <a:prstGeom prst="ellipse">
@@ -4814,7 +4810,7 @@
         </p:nvSpPr>
         <p:spPr>
           <a:xfrm>
-            <a:off x="1879600" y="19088100"/>
+            <a:off x="1879600" y="19443700"/>
             <a:ext cx="6604000" cy="381000"/>
           </a:xfrm>
           <a:prstGeom prst="rect">
@@ -4849,7 +4845,7 @@
         </p:nvSpPr>
         <p:spPr>
           <a:xfrm>
-            <a:off x="1574800" y="19608800"/>
+            <a:off x="1574800" y="19964400"/>
             <a:ext cx="139700" cy="139700"/>
           </a:xfrm>
           <a:prstGeom prst="ellipse">
@@ -4877,7 +4873,7 @@
         </p:nvSpPr>
         <p:spPr>
           <a:xfrm>
-            <a:off x="1879600" y="19494500"/>
+            <a:off x="1879600" y="19850100"/>
             <a:ext cx="6604000" cy="381000"/>
           </a:xfrm>
           <a:prstGeom prst="rect">
@@ -4912,8 +4908,8 @@
         </p:nvSpPr>
         <p:spPr>
           <a:xfrm>
-            <a:off x="9093200" y="15900400"/>
-            <a:ext cx="3454400" cy="3962400"/>
+            <a:off x="9093200" y="16256000"/>
+            <a:ext cx="3454400" cy="3860800"/>
           </a:xfrm>
           <a:prstGeom prst="roundRect">
             <a:avLst>
@@ -4942,7 +4938,7 @@
         </p:nvSpPr>
         <p:spPr>
           <a:xfrm>
-            <a:off x="762000" y="20701000"/>
+            <a:off x="762000" y="20955000"/>
             <a:ext cx="12192000" cy="1778000"/>
           </a:xfrm>
           <a:prstGeom prst="roundRect">
@@ -4980,7 +4976,7 @@
         </p:nvSpPr>
         <p:spPr>
           <a:xfrm>
-            <a:off x="1219200" y="21082000"/>
+            <a:off x="1219200" y="21336000"/>
             <a:ext cx="1016000" cy="1016000"/>
           </a:xfrm>
           <a:prstGeom prst="ellipse">
@@ -5002,22 +4998,22 @@
       </p:sp>
       <p:pic>
         <p:nvPicPr>
-          <p:cNvPr id="71" name="Picture 70" descr="target_dk.png"/>
+          <p:cNvPr id="98" name="Picture 97" descr="ph_target-fill_3D2159.png"/>
           <p:cNvPicPr>
             <a:picLocks noChangeAspect="1"/>
           </p:cNvPicPr>
           <p:nvPr/>
         </p:nvPicPr>
         <p:blipFill>
-          <a:blip r:embed="rId10"/>
+          <a:blip r:embed="rId25"/>
           <a:stretch>
             <a:fillRect/>
           </a:stretch>
         </p:blipFill>
         <p:spPr>
           <a:xfrm>
-            <a:off x="1447800" y="21310600"/>
-            <a:ext cx="558800" cy="558800"/>
+            <a:off x="1422400" y="21539200"/>
+            <a:ext cx="609600" cy="609600"/>
           </a:xfrm>
           <a:prstGeom prst="rect">
             <a:avLst/>
@@ -5032,7 +5028,7 @@
         </p:nvSpPr>
         <p:spPr>
           <a:xfrm>
-            <a:off x="2616200" y="20980400"/>
+            <a:off x="2616200" y="21234400"/>
             <a:ext cx="3175000" cy="431800"/>
           </a:xfrm>
           <a:prstGeom prst="roundRect">
@@ -5062,7 +5058,7 @@
         </p:nvSpPr>
         <p:spPr>
           <a:xfrm>
-            <a:off x="2616200" y="20980400"/>
+            <a:off x="2616200" y="21234400"/>
             <a:ext cx="3175000" cy="431800"/>
           </a:xfrm>
           <a:prstGeom prst="rect">
@@ -5097,7 +5093,7 @@
         </p:nvSpPr>
         <p:spPr>
           <a:xfrm>
-            <a:off x="2616200" y="21513800"/>
+            <a:off x="2616200" y="21767800"/>
             <a:ext cx="9906000" cy="762000"/>
           </a:xfrm>
           <a:prstGeom prst="rect">
@@ -5211,28 +5207,22 @@
       </p:pic>
       <p:pic>
         <p:nvPicPr>
-          <p:cNvPr id="77" name="Picture 76" descr="">
-            <a:extLst>
-              <a:ext uri="{C183D7F6-B498-43B3-948B-1728B52AA6E4}">
-                <adec:decorative xmlns:adec="http://schemas.microsoft.com/office/drawing/2017/decorative" val="1"/>
-              </a:ext>
-            </a:extLst>
-          </p:cNvPr>
+          <p:cNvPr id="90" name="Picture 89" descr="ph_lightbulb-filament-fill_E0B000.png"/>
           <p:cNvPicPr>
             <a:picLocks noChangeAspect="1"/>
           </p:cNvPicPr>
           <p:nvPr/>
         </p:nvPicPr>
         <p:blipFill>
-          <a:blip r:embed="rId12"/>
+          <a:blip r:embed="rId18"/>
           <a:stretch>
             <a:fillRect/>
           </a:stretch>
         </p:blipFill>
         <p:spPr>
           <a:xfrm>
-            <a:off x="10248900" y="5537200"/>
-            <a:ext cx="1143000" cy="1143000"/>
+            <a:off x="10172700" y="5410200"/>
+            <a:ext cx="1295400" cy="1295400"/>
           </a:xfrm>
           <a:prstGeom prst="rect">
             <a:avLst/>
@@ -5253,7 +5243,7 @@
         </p:nvSpPr>
         <p:spPr>
           <a:xfrm>
-            <a:off x="9321800" y="6985000"/>
+            <a:off x="9321800" y="6934200"/>
             <a:ext cx="2997200" cy="1524000"/>
           </a:xfrm>
           <a:prstGeom prst="roundRect">
@@ -5265,9 +5255,7 @@
             <a:srgbClr val="FFFFFF"/>
           </a:solidFill>
           <a:ln w="19050">
-            <a:solidFill>
-              <a:srgbClr val="F2C200"/>
-            </a:solidFill>
+            <a:noFill/>
           </a:ln>
           <a:effectLst/>
         </p:spPr>
@@ -5281,22 +5269,22 @@
       </p:sp>
       <p:pic>
         <p:nvPicPr>
-          <p:cNvPr id="26" name="Picture 25" descr="quote_dk.png"/>
+          <p:cNvPr id="93" name="Picture 92" descr="ph_quotes-fill_C9A000.png"/>
           <p:cNvPicPr>
             <a:picLocks noChangeAspect="1"/>
           </p:cNvPicPr>
           <p:nvPr/>
         </p:nvPicPr>
         <p:blipFill>
-          <a:blip r:embed="rId4"/>
+          <a:blip r:embed="rId21"/>
           <a:stretch>
             <a:fillRect/>
           </a:stretch>
         </p:blipFill>
         <p:spPr>
           <a:xfrm>
-            <a:off x="9601200" y="7213600"/>
-            <a:ext cx="355600" cy="355600"/>
+            <a:off x="9575800" y="7137400"/>
+            <a:ext cx="406400" cy="406400"/>
           </a:xfrm>
           <a:prstGeom prst="rect">
             <a:avLst/>
@@ -5311,7 +5299,7 @@
         </p:nvSpPr>
         <p:spPr>
           <a:xfrm>
-            <a:off x="9601200" y="7645400"/>
+            <a:off x="9601200" y="7594600"/>
             <a:ext cx="2489200" cy="762000"/>
           </a:xfrm>
           <a:prstGeom prst="rect">
@@ -5344,28 +5332,22 @@
       </p:sp>
       <p:pic>
         <p:nvPicPr>
-          <p:cNvPr id="80" name="Picture 79" descr="">
-            <a:extLst>
-              <a:ext uri="{C183D7F6-B498-43B3-948B-1728B52AA6E4}">
-                <adec:decorative xmlns:adec="http://schemas.microsoft.com/office/drawing/2017/decorative" val="1"/>
-              </a:ext>
-            </a:extLst>
-          </p:cNvPr>
+          <p:cNvPr id="91" name="Picture 90" descr="ph_note-pencil-fill_8A63B8.png"/>
           <p:cNvPicPr>
             <a:picLocks noChangeAspect="1"/>
           </p:cNvPicPr>
           <p:nvPr/>
         </p:nvPicPr>
         <p:blipFill>
-          <a:blip r:embed="rId13"/>
+          <a:blip r:embed="rId19"/>
           <a:stretch>
             <a:fillRect/>
           </a:stretch>
         </p:blipFill>
         <p:spPr>
           <a:xfrm>
-            <a:off x="10248900" y="10871200"/>
-            <a:ext cx="1143000" cy="1143000"/>
+            <a:off x="10172700" y="10947400"/>
+            <a:ext cx="1295400" cy="1295400"/>
           </a:xfrm>
           <a:prstGeom prst="rect">
             <a:avLst/>
@@ -5386,7 +5368,7 @@
         </p:nvSpPr>
         <p:spPr>
           <a:xfrm>
-            <a:off x="9321800" y="12319000"/>
+            <a:off x="9321800" y="12471400"/>
             <a:ext cx="2997200" cy="1524000"/>
           </a:xfrm>
           <a:prstGeom prst="roundRect">
@@ -5398,9 +5380,7 @@
             <a:srgbClr val="FFFFFF"/>
           </a:solidFill>
           <a:ln w="19050">
-            <a:solidFill>
-              <a:srgbClr val="664092"/>
-            </a:solidFill>
+            <a:noFill/>
           </a:ln>
           <a:effectLst/>
         </p:spPr>
@@ -5414,22 +5394,22 @@
       </p:sp>
       <p:pic>
         <p:nvPicPr>
-          <p:cNvPr id="46" name="Picture 45" descr="quote_pu.png"/>
+          <p:cNvPr id="94" name="Picture 93" descr="ph_quotes-fill_664092.png"/>
           <p:cNvPicPr>
             <a:picLocks noChangeAspect="1"/>
           </p:cNvPicPr>
           <p:nvPr/>
         </p:nvPicPr>
         <p:blipFill>
-          <a:blip r:embed="rId7"/>
+          <a:blip r:embed="rId22"/>
           <a:stretch>
             <a:fillRect/>
           </a:stretch>
         </p:blipFill>
         <p:spPr>
           <a:xfrm>
-            <a:off x="9601200" y="12547600"/>
-            <a:ext cx="355600" cy="355600"/>
+            <a:off x="9575800" y="12674600"/>
+            <a:ext cx="406400" cy="406400"/>
           </a:xfrm>
           <a:prstGeom prst="rect">
             <a:avLst/>
@@ -5444,7 +5424,7 @@
         </p:nvSpPr>
         <p:spPr>
           <a:xfrm>
-            <a:off x="9601200" y="12979400"/>
+            <a:off x="9601200" y="13131800"/>
             <a:ext cx="2489200" cy="762000"/>
           </a:xfrm>
           <a:prstGeom prst="rect">
@@ -5477,28 +5457,22 @@
       </p:sp>
       <p:pic>
         <p:nvPicPr>
-          <p:cNvPr id="83" name="Picture 82" descr="">
-            <a:extLst>
-              <a:ext uri="{C183D7F6-B498-43B3-948B-1728B52AA6E4}">
-                <adec:decorative xmlns:adec="http://schemas.microsoft.com/office/drawing/2017/decorative" val="1"/>
-              </a:ext>
-            </a:extLst>
-          </p:cNvPr>
+          <p:cNvPr id="92" name="Picture 91" descr="ph_cube-fill_5E83D6.png"/>
           <p:cNvPicPr>
             <a:picLocks noChangeAspect="1"/>
           </p:cNvPicPr>
           <p:nvPr/>
         </p:nvPicPr>
         <p:blipFill>
-          <a:blip r:embed="rId14"/>
+          <a:blip r:embed="rId20"/>
           <a:stretch>
             <a:fillRect/>
           </a:stretch>
         </p:blipFill>
         <p:spPr>
           <a:xfrm>
-            <a:off x="10248900" y="16205200"/>
-            <a:ext cx="1143000" cy="1143000"/>
+            <a:off x="10172700" y="16484600"/>
+            <a:ext cx="1295400" cy="1295400"/>
           </a:xfrm>
           <a:prstGeom prst="rect">
             <a:avLst/>
@@ -5519,7 +5493,7 @@
         </p:nvSpPr>
         <p:spPr>
           <a:xfrm>
-            <a:off x="9321800" y="17653000"/>
+            <a:off x="9321800" y="18008600"/>
             <a:ext cx="2997200" cy="1524000"/>
           </a:xfrm>
           <a:prstGeom prst="roundRect">
@@ -5531,9 +5505,7 @@
             <a:srgbClr val="FFFFFF"/>
           </a:solidFill>
           <a:ln w="19050">
-            <a:solidFill>
-              <a:srgbClr val="2A56C6"/>
-            </a:solidFill>
+            <a:noFill/>
           </a:ln>
           <a:effectLst/>
         </p:spPr>
@@ -5547,22 +5519,22 @@
       </p:sp>
       <p:pic>
         <p:nvPicPr>
-          <p:cNvPr id="66" name="Picture 65" descr="quote_bl.png"/>
+          <p:cNvPr id="95" name="Picture 94" descr="ph_quotes-fill_2A56C6.png"/>
           <p:cNvPicPr>
             <a:picLocks noChangeAspect="1"/>
           </p:cNvPicPr>
           <p:nvPr/>
         </p:nvPicPr>
         <p:blipFill>
-          <a:blip r:embed="rId9"/>
+          <a:blip r:embed="rId23"/>
           <a:stretch>
             <a:fillRect/>
           </a:stretch>
         </p:blipFill>
         <p:spPr>
           <a:xfrm>
-            <a:off x="9601200" y="17881600"/>
-            <a:ext cx="355600" cy="355600"/>
+            <a:off x="9575800" y="18211800"/>
+            <a:ext cx="406400" cy="406400"/>
           </a:xfrm>
           <a:prstGeom prst="rect">
             <a:avLst/>
@@ -5577,7 +5549,7 @@
         </p:nvSpPr>
         <p:spPr>
           <a:xfrm>
-            <a:off x="9601200" y="18313400"/>
+            <a:off x="9601200" y="18669000"/>
             <a:ext cx="2489200" cy="762000"/>
           </a:xfrm>
           <a:prstGeom prst="rect">

</xml_diff>